<commit_message>
Show full matching flow on overview slide and Consent as an object in data model
Co-Authored-By: Claude Opus 5.5 <noreply@anthropic.com>
Claude-Session: https://claude.ai/code/session_01UEyZwgtPKErqguEM4x8Yck
</commit_message>
<xml_diff>
--- a/slides/France_CBU_Congress_Solution.pptx
+++ b/slides/France_CBU_Congress_Solution.pptx
@@ -115,30 +115,30 @@
   <p:extLst>
     <p:ext uri="{521415D9-36F7-43E2-AB2F-B90AF26B5E84}">
       <p14:sectionLst xmlns:p14="http://schemas.microsoft.com/office/powerpoint/2010/main">
-        <p14:section name="Intro" id="{3ff11d71-0071-79b8-5662-dce091551f13}">
+        <p14:section name="Intro" id="{ff3d981e-cc07-0ee1-305f-b98b99ad2236}">
           <p14:sldIdLst>
             <p14:sldId id="256"/>
           </p14:sldIdLst>
         </p14:section>
-        <p14:section name="Context" id="{bcef5e61-8f9a-44da-a7fb-de6a14489104}">
+        <p14:section name="Context" id="{7e55843f-f7e5-9d3d-a108-f98c400d4e5e}">
           <p14:sldIdLst>
             <p14:sldId id="257"/>
           </p14:sldIdLst>
         </p14:section>
-        <p14:section name="Solution" id="{28c54704-3ec7-5923-e4d0-8d433b9f6948}">
+        <p14:section name="Solution" id="{6320d282-b5cf-b34d-120a-c8eb5d67348d}">
           <p14:sldIdLst>
             <p14:sldId id="258"/>
             <p14:sldId id="259"/>
             <p14:sldId id="260"/>
           </p14:sldIdLst>
         </p14:section>
-        <p14:section name="Visit" id="{9378fa49-8b7a-01ed-b031-f730038d472e}">
+        <p14:section name="Visit" id="{0eb53bcc-72ed-b63e-b967-9defac5fdc33}">
           <p14:sldIdLst>
             <p14:sldId id="261"/>
             <p14:sldId id="262"/>
           </p14:sldIdLst>
         </p14:section>
-        <p14:section name="Next steps" id="{d3517c77-83aa-7fee-1162-ee2ea597d422}">
+        <p14:section name="Next steps" id="{2b2133fd-37a0-c896-05d7-fed0ce6d3a31}">
           <p14:sldIdLst>
             <p14:sldId id="263"/>
             <p14:sldId id="264"/>
@@ -724,7 +724,7 @@
           <a:p>
             <a:r>
               <a:rPr lang="en-US" dirty="0"/>
-              <a:t>Congress and invitations reuse what exists today. Capture, matching and Visit are the new customization.</a:t>
+              <a:t>Three channels feed one Capture. Matching links it to the right HCP record (auto-match, steward review or new HCP). Then the consent record is created and sent to Gigya, and Apex creates the Visit on the HCP.</a:t>
             </a:r>
             <a:endParaRPr lang="en-US" dirty="0"/>
           </a:p>
@@ -2513,12 +2513,12 @@
         </p:nvSpPr>
         <p:spPr>
           <a:xfrm>
-            <a:off x="457200" y="1188720"/>
-            <a:ext cx="1828800" cy="2560320"/>
+            <a:off x="457200" y="1005840"/>
+            <a:ext cx="1828800" cy="548640"/>
           </a:xfrm>
           <a:prstGeom prst="roundRect">
             <a:avLst>
-              <a:gd name="adj" fmla="val 4000"/>
+              <a:gd name="adj" fmla="val 13333"/>
             </a:avLst>
           </a:prstGeom>
           <a:solidFill>
@@ -2534,24 +2534,76 @@
       </p:sp>
       <p:sp>
         <p:nvSpPr>
-          <p:cNvPr id="4" name="Shape 2"/>
+          <p:cNvPr id="4" name="Text 2"/>
+          <p:cNvSpPr txBox="1"/>
+          <p:nvPr/>
+        </p:nvSpPr>
+        <p:spPr>
+          <a:xfrm>
+            <a:off x="502920" y="1005840"/>
+            <a:ext cx="1737360" cy="548640"/>
+          </a:xfrm>
+          <a:prstGeom prst="rect">
+            <a:avLst/>
+          </a:prstGeom>
+          <a:noFill/>
+          <a:ln/>
+        </p:spPr>
+        <p:txBody>
+          <a:bodyPr wrap="square" lIns="0" tIns="0" rIns="0" bIns="0" rtlCol="0" anchor="ctr"/>
+          <a:lstStyle/>
+          <a:p>
+            <a:pPr algn="ctr" indent="0" marL="0">
+              <a:buNone/>
+            </a:pPr>
+            <a:r>
+              <a:rPr lang="en-US" sz="1300" b="1" dirty="0">
+                <a:solidFill>
+                  <a:schemeClr val="accent1"/>
+                </a:solidFill>
+              </a:rPr>
+              <a:t>QR self-scan</a:t>
+            </a:r>
+            <a:endParaRPr lang="en-US" sz="1400" dirty="0"/>
+          </a:p>
+          <a:p>
+            <a:pPr algn="ctr" indent="0" marL="0">
+              <a:buNone/>
+            </a:pPr>
+            <a:r>
+              <a:rPr lang="en-US" sz="1100" dirty="0">
+                <a:solidFill>
+                  <a:schemeClr val="tx1"/>
+                </a:solidFill>
+              </a:rPr>
+              <a:t>HCP phone at the booth</a:t>
+            </a:r>
+            <a:endParaRPr lang="en-US" sz="1400" dirty="0"/>
+          </a:p>
+        </p:txBody>
+      </p:sp>
+      <p:sp>
+        <p:nvSpPr>
+          <p:cNvPr id="5" name="Shape 3"/>
           <p:cNvSpPr/>
           <p:nvPr/>
         </p:nvSpPr>
         <p:spPr>
           <a:xfrm>
-            <a:off x="1097280" y="1371600"/>
-            <a:ext cx="548640" cy="548640"/>
-          </a:xfrm>
-          <a:prstGeom prst="ellipse">
-            <a:avLst/>
+            <a:off x="2468880" y="1005840"/>
+            <a:ext cx="1828800" cy="548640"/>
+          </a:xfrm>
+          <a:prstGeom prst="roundRect">
+            <a:avLst>
+              <a:gd name="adj" fmla="val 13333"/>
+            </a:avLst>
           </a:prstGeom>
           <a:solidFill>
-            <a:schemeClr val="accent3"/>
+            <a:schemeClr val="bg2"/>
           </a:solidFill>
           <a:ln w="12700">
             <a:solidFill>
-              <a:schemeClr val="accent3"/>
+              <a:schemeClr val="bg2"/>
             </a:solidFill>
             <a:prstDash val="solid"/>
           </a:ln>
@@ -2559,124 +2611,166 @@
       </p:sp>
       <p:sp>
         <p:nvSpPr>
-          <p:cNvPr id="5" name="Text 3"/>
-          <p:cNvSpPr txBox="1"/>
-          <p:nvPr/>
-        </p:nvSpPr>
-        <p:spPr>
-          <a:xfrm>
-            <a:off x="1097280" y="1371600"/>
-            <a:ext cx="548640" cy="548640"/>
-          </a:xfrm>
-          <a:prstGeom prst="rect">
-            <a:avLst/>
-          </a:prstGeom>
-          <a:noFill/>
-          <a:ln/>
-        </p:spPr>
-        <p:txBody>
-          <a:bodyPr wrap="square" lIns="0" tIns="0" rIns="0" bIns="0" rtlCol="0" anchor="ctr"/>
-          <a:lstStyle/>
-          <a:p>
-            <a:pPr algn="ctr" indent="0" marL="0">
-              <a:buNone/>
-            </a:pPr>
-            <a:r>
-              <a:rPr lang="en-US" sz="1600" b="1" dirty="0">
-                <a:solidFill>
-                  <a:schemeClr val="bg1"/>
-                </a:solidFill>
-              </a:rPr>
-              <a:t>1</a:t>
-            </a:r>
-            <a:endParaRPr lang="en-US" sz="1600" dirty="0"/>
-          </a:p>
-        </p:txBody>
-      </p:sp>
-      <p:sp>
-        <p:nvSpPr>
           <p:cNvPr id="6" name="Text 4"/>
           <p:cNvSpPr txBox="1"/>
           <p:nvPr/>
         </p:nvSpPr>
         <p:spPr>
           <a:xfrm>
-            <a:off x="548640" y="2057400"/>
-            <a:ext cx="1645920" cy="411480"/>
-          </a:xfrm>
-          <a:prstGeom prst="rect">
-            <a:avLst/>
-          </a:prstGeom>
-          <a:noFill/>
-          <a:ln/>
-        </p:spPr>
-        <p:txBody>
-          <a:bodyPr wrap="square" lIns="0" tIns="0" rIns="0" bIns="0" rtlCol="0" anchor="t"/>
+            <a:off x="2514600" y="1005840"/>
+            <a:ext cx="1737360" cy="548640"/>
+          </a:xfrm>
+          <a:prstGeom prst="rect">
+            <a:avLst/>
+          </a:prstGeom>
+          <a:noFill/>
+          <a:ln/>
+        </p:spPr>
+        <p:txBody>
+          <a:bodyPr wrap="square" lIns="0" tIns="0" rIns="0" bIns="0" rtlCol="0" anchor="ctr"/>
           <a:lstStyle/>
           <a:p>
             <a:pPr algn="ctr" indent="0" marL="0">
               <a:buNone/>
             </a:pPr>
             <a:r>
-              <a:rPr lang="en-US" sz="1600" b="1" dirty="0">
+              <a:rPr lang="en-US" sz="1300" b="1" dirty="0">
                 <a:solidFill>
                   <a:schemeClr val="accent1"/>
                 </a:solidFill>
               </a:rPr>
-              <a:t>Congress</a:t>
-            </a:r>
-            <a:endParaRPr lang="en-US" sz="1600" dirty="0"/>
-          </a:p>
-        </p:txBody>
-      </p:sp>
-      <p:sp>
-        <p:nvSpPr>
-          <p:cNvPr id="7" name="Text 5"/>
+              <a:t>Kiosk</a:t>
+            </a:r>
+            <a:endParaRPr lang="en-US" sz="1400" dirty="0"/>
+          </a:p>
+          <a:p>
+            <a:pPr algn="ctr" indent="0" marL="0">
+              <a:buNone/>
+            </a:pPr>
+            <a:r>
+              <a:rPr lang="en-US" sz="1100" dirty="0">
+                <a:solidFill>
+                  <a:schemeClr val="tx1"/>
+                </a:solidFill>
+              </a:rPr>
+              <a:t>shared tablet at a training</a:t>
+            </a:r>
+            <a:endParaRPr lang="en-US" sz="1400" dirty="0"/>
+          </a:p>
+        </p:txBody>
+      </p:sp>
+      <p:sp>
+        <p:nvSpPr>
+          <p:cNvPr id="7" name="Shape 5"/>
+          <p:cNvSpPr/>
+          <p:nvPr/>
+        </p:nvSpPr>
+        <p:spPr>
+          <a:xfrm>
+            <a:off x="4480560" y="1005840"/>
+            <a:ext cx="1828800" cy="548640"/>
+          </a:xfrm>
+          <a:prstGeom prst="roundRect">
+            <a:avLst>
+              <a:gd name="adj" fmla="val 13333"/>
+            </a:avLst>
+          </a:prstGeom>
+          <a:solidFill>
+            <a:schemeClr val="bg2"/>
+          </a:solidFill>
+          <a:ln w="12700">
+            <a:solidFill>
+              <a:schemeClr val="bg2"/>
+            </a:solidFill>
+            <a:prstDash val="solid"/>
+          </a:ln>
+        </p:spPr>
+      </p:sp>
+      <p:sp>
+        <p:nvSpPr>
+          <p:cNvPr id="8" name="Text 6"/>
           <p:cNvSpPr txBox="1"/>
           <p:nvPr/>
         </p:nvSpPr>
         <p:spPr>
           <a:xfrm>
-            <a:off x="594360" y="2514600"/>
-            <a:ext cx="1554480" cy="1143000"/>
-          </a:xfrm>
-          <a:prstGeom prst="rect">
-            <a:avLst/>
-          </a:prstGeom>
-          <a:noFill/>
-          <a:ln/>
-        </p:spPr>
-        <p:txBody>
-          <a:bodyPr wrap="square" lIns="0" tIns="0" rIns="0" bIns="0" rtlCol="0" anchor="t"/>
+            <a:off x="4526280" y="1005840"/>
+            <a:ext cx="1737360" cy="548640"/>
+          </a:xfrm>
+          <a:prstGeom prst="rect">
+            <a:avLst/>
+          </a:prstGeom>
+          <a:noFill/>
+          <a:ln/>
+        </p:spPr>
+        <p:txBody>
+          <a:bodyPr wrap="square" lIns="0" tIns="0" rIns="0" bIns="0" rtlCol="0" anchor="ctr"/>
           <a:lstStyle/>
           <a:p>
             <a:pPr algn="ctr" indent="0" marL="0">
               <a:buNone/>
             </a:pPr>
             <a:r>
-              <a:rPr lang="en-US" sz="1200" dirty="0">
+              <a:rPr lang="en-US" sz="1300" b="1" dirty="0">
+                <a:solidFill>
+                  <a:schemeClr val="accent1"/>
+                </a:solidFill>
+              </a:rPr>
+              <a:t>Rep page</a:t>
+            </a:r>
+            <a:endParaRPr lang="en-US" sz="1400" dirty="0"/>
+          </a:p>
+          <a:p>
+            <a:pPr algn="ctr" indent="0" marL="0">
+              <a:buNone/>
+            </a:pPr>
+            <a:r>
+              <a:rPr lang="en-US" sz="1100" dirty="0">
                 <a:solidFill>
                   <a:schemeClr val="tx1"/>
                 </a:solidFill>
               </a:rPr>
-              <a:t>Created with dates, venue and invited attendees</a:t>
-            </a:r>
-            <a:endParaRPr lang="en-US" sz="1200" dirty="0"/>
-          </a:p>
-        </p:txBody>
-      </p:sp>
-      <p:sp>
-        <p:nvSpPr>
-          <p:cNvPr id="8" name="Shape 6"/>
+              <a:t>rep phone, search first</a:t>
+            </a:r>
+            <a:endParaRPr lang="en-US" sz="1400" dirty="0"/>
+          </a:p>
+        </p:txBody>
+      </p:sp>
+      <p:sp>
+        <p:nvSpPr>
+          <p:cNvPr id="9" name="Shape 7"/>
           <p:cNvSpPr/>
           <p:nvPr/>
         </p:nvSpPr>
         <p:spPr>
           <a:xfrm>
-            <a:off x="2313432" y="2331720"/>
-            <a:ext cx="265176" cy="274320"/>
-          </a:xfrm>
-          <a:prstGeom prst="rightArrow">
+            <a:off x="1371600" y="1664208"/>
+            <a:ext cx="4023360" cy="0"/>
+          </a:xfrm>
+          <a:prstGeom prst="line">
+            <a:avLst/>
+          </a:prstGeom>
+          <a:noFill/>
+          <a:ln w="15875">
+            <a:solidFill>
+              <a:schemeClr val="accent4"/>
+            </a:solidFill>
+            <a:prstDash val="solid"/>
+          </a:ln>
+        </p:spPr>
+      </p:sp>
+      <p:sp>
+        <p:nvSpPr>
+          <p:cNvPr id="10" name="Shape 8"/>
+          <p:cNvSpPr/>
+          <p:nvPr/>
+        </p:nvSpPr>
+        <p:spPr>
+          <a:xfrm>
+            <a:off x="3282696" y="1664208"/>
+            <a:ext cx="201168" cy="182880"/>
+          </a:xfrm>
+          <a:prstGeom prst="downArrow">
             <a:avLst/>
           </a:prstGeom>
           <a:solidFill>
@@ -2692,18 +2786,245 @@
       </p:sp>
       <p:sp>
         <p:nvSpPr>
-          <p:cNvPr id="9" name="Shape 7"/>
+          <p:cNvPr id="11" name="Shape 9"/>
           <p:cNvSpPr/>
           <p:nvPr/>
         </p:nvSpPr>
         <p:spPr>
           <a:xfrm>
-            <a:off x="2606040" y="1188720"/>
-            <a:ext cx="1828800" cy="2560320"/>
+            <a:off x="2377440" y="1874520"/>
+            <a:ext cx="2011680" cy="548640"/>
           </a:xfrm>
           <a:prstGeom prst="roundRect">
             <a:avLst>
-              <a:gd name="adj" fmla="val 4000"/>
+              <a:gd name="adj" fmla="val 13333"/>
+            </a:avLst>
+          </a:prstGeom>
+          <a:solidFill>
+            <a:srgbClr val="FBE3DC"/>
+          </a:solidFill>
+          <a:ln w="12700">
+            <a:solidFill>
+              <a:srgbClr val="FBE3DC"/>
+            </a:solidFill>
+            <a:prstDash val="solid"/>
+          </a:ln>
+        </p:spPr>
+      </p:sp>
+      <p:sp>
+        <p:nvSpPr>
+          <p:cNvPr id="12" name="Text 10"/>
+          <p:cNvSpPr txBox="1"/>
+          <p:nvPr/>
+        </p:nvSpPr>
+        <p:spPr>
+          <a:xfrm>
+            <a:off x="2423160" y="1874520"/>
+            <a:ext cx="1920240" cy="548640"/>
+          </a:xfrm>
+          <a:prstGeom prst="rect">
+            <a:avLst/>
+          </a:prstGeom>
+          <a:noFill/>
+          <a:ln/>
+        </p:spPr>
+        <p:txBody>
+          <a:bodyPr wrap="square" lIns="0" tIns="0" rIns="0" bIns="0" rtlCol="0" anchor="ctr"/>
+          <a:lstStyle/>
+          <a:p>
+            <a:pPr algn="ctr" indent="0" marL="0">
+              <a:buNone/>
+            </a:pPr>
+            <a:r>
+              <a:rPr lang="en-US" sz="1300" b="1" dirty="0">
+                <a:solidFill>
+                  <a:schemeClr val="accent2"/>
+                </a:solidFill>
+              </a:rPr>
+              <a:t>Capture</a:t>
+            </a:r>
+            <a:endParaRPr lang="en-US" sz="1400" dirty="0"/>
+          </a:p>
+          <a:p>
+            <a:pPr algn="ctr" indent="0" marL="0">
+              <a:buNone/>
+            </a:pPr>
+            <a:r>
+              <a:rPr lang="en-US" sz="1100" dirty="0">
+                <a:solidFill>
+                  <a:schemeClr val="tx1"/>
+                </a:solidFill>
+              </a:rPr>
+              <a:t>one staging record per sign-up</a:t>
+            </a:r>
+            <a:endParaRPr lang="en-US" sz="1400" dirty="0"/>
+          </a:p>
+        </p:txBody>
+      </p:sp>
+      <p:sp>
+        <p:nvSpPr>
+          <p:cNvPr id="13" name="Shape 11"/>
+          <p:cNvSpPr/>
+          <p:nvPr/>
+        </p:nvSpPr>
+        <p:spPr>
+          <a:xfrm>
+            <a:off x="3282696" y="2441448"/>
+            <a:ext cx="201168" cy="164592"/>
+          </a:xfrm>
+          <a:prstGeom prst="downArrow">
+            <a:avLst/>
+          </a:prstGeom>
+          <a:solidFill>
+            <a:schemeClr val="accent4"/>
+          </a:solidFill>
+          <a:ln w="12700">
+            <a:solidFill>
+              <a:schemeClr val="accent4"/>
+            </a:solidFill>
+            <a:prstDash val="solid"/>
+          </a:ln>
+        </p:spPr>
+      </p:sp>
+      <p:sp>
+        <p:nvSpPr>
+          <p:cNvPr id="14" name="Shape 12"/>
+          <p:cNvSpPr/>
+          <p:nvPr/>
+        </p:nvSpPr>
+        <p:spPr>
+          <a:xfrm>
+            <a:off x="2377440" y="2624328"/>
+            <a:ext cx="2011680" cy="548640"/>
+          </a:xfrm>
+          <a:prstGeom prst="roundRect">
+            <a:avLst>
+              <a:gd name="adj" fmla="val 13333"/>
+            </a:avLst>
+          </a:prstGeom>
+          <a:solidFill>
+            <a:srgbClr val="FBE3DC"/>
+          </a:solidFill>
+          <a:ln w="12700">
+            <a:solidFill>
+              <a:srgbClr val="FBE3DC"/>
+            </a:solidFill>
+            <a:prstDash val="solid"/>
+          </a:ln>
+        </p:spPr>
+      </p:sp>
+      <p:sp>
+        <p:nvSpPr>
+          <p:cNvPr id="15" name="Text 13"/>
+          <p:cNvSpPr txBox="1"/>
+          <p:nvPr/>
+        </p:nvSpPr>
+        <p:spPr>
+          <a:xfrm>
+            <a:off x="2423160" y="2624328"/>
+            <a:ext cx="1920240" cy="548640"/>
+          </a:xfrm>
+          <a:prstGeom prst="rect">
+            <a:avLst/>
+          </a:prstGeom>
+          <a:noFill/>
+          <a:ln/>
+        </p:spPr>
+        <p:txBody>
+          <a:bodyPr wrap="square" lIns="0" tIns="0" rIns="0" bIns="0" rtlCol="0" anchor="ctr"/>
+          <a:lstStyle/>
+          <a:p>
+            <a:pPr algn="ctr" indent="0" marL="0">
+              <a:buNone/>
+            </a:pPr>
+            <a:r>
+              <a:rPr lang="en-US" sz="1300" b="1" dirty="0">
+                <a:solidFill>
+                  <a:schemeClr val="accent2"/>
+                </a:solidFill>
+              </a:rPr>
+              <a:t>Automatic matching</a:t>
+            </a:r>
+            <a:endParaRPr lang="en-US" sz="1400" dirty="0"/>
+          </a:p>
+          <a:p>
+            <a:pPr algn="ctr" indent="0" marL="0">
+              <a:buNone/>
+            </a:pPr>
+            <a:r>
+              <a:rPr lang="en-US" sz="1100" dirty="0">
+                <a:solidFill>
+                  <a:schemeClr val="tx1"/>
+                </a:solidFill>
+              </a:rPr>
+              <a:t>in the background, in seconds</a:t>
+            </a:r>
+            <a:endParaRPr lang="en-US" sz="1400" dirty="0"/>
+          </a:p>
+        </p:txBody>
+      </p:sp>
+      <p:sp>
+        <p:nvSpPr>
+          <p:cNvPr id="16" name="Shape 14"/>
+          <p:cNvSpPr/>
+          <p:nvPr/>
+        </p:nvSpPr>
+        <p:spPr>
+          <a:xfrm>
+            <a:off x="1371600" y="3310128"/>
+            <a:ext cx="4023360" cy="0"/>
+          </a:xfrm>
+          <a:prstGeom prst="line">
+            <a:avLst/>
+          </a:prstGeom>
+          <a:noFill/>
+          <a:ln w="15875">
+            <a:solidFill>
+              <a:schemeClr val="accent4"/>
+            </a:solidFill>
+            <a:prstDash val="solid"/>
+          </a:ln>
+        </p:spPr>
+      </p:sp>
+      <p:sp>
+        <p:nvSpPr>
+          <p:cNvPr id="17" name="Shape 15"/>
+          <p:cNvSpPr/>
+          <p:nvPr/>
+        </p:nvSpPr>
+        <p:spPr>
+          <a:xfrm>
+            <a:off x="3282696" y="3191256"/>
+            <a:ext cx="201168" cy="182880"/>
+          </a:xfrm>
+          <a:prstGeom prst="downArrow">
+            <a:avLst/>
+          </a:prstGeom>
+          <a:solidFill>
+            <a:schemeClr val="accent4"/>
+          </a:solidFill>
+          <a:ln w="12700">
+            <a:solidFill>
+              <a:schemeClr val="accent4"/>
+            </a:solidFill>
+            <a:prstDash val="solid"/>
+          </a:ln>
+        </p:spPr>
+      </p:sp>
+      <p:sp>
+        <p:nvSpPr>
+          <p:cNvPr id="18" name="Shape 16"/>
+          <p:cNvSpPr/>
+          <p:nvPr/>
+        </p:nvSpPr>
+        <p:spPr>
+          <a:xfrm>
+            <a:off x="457200" y="3401568"/>
+            <a:ext cx="1828800" cy="548640"/>
+          </a:xfrm>
+          <a:prstGeom prst="roundRect">
+            <a:avLst>
+              <a:gd name="adj" fmla="val 13333"/>
             </a:avLst>
           </a:prstGeom>
           <a:solidFill>
@@ -2719,16 +3040,268 @@
       </p:sp>
       <p:sp>
         <p:nvSpPr>
-          <p:cNvPr id="10" name="Shape 8"/>
+          <p:cNvPr id="19" name="Text 17"/>
+          <p:cNvSpPr txBox="1"/>
+          <p:nvPr/>
+        </p:nvSpPr>
+        <p:spPr>
+          <a:xfrm>
+            <a:off x="502920" y="3401568"/>
+            <a:ext cx="1737360" cy="548640"/>
+          </a:xfrm>
+          <a:prstGeom prst="rect">
+            <a:avLst/>
+          </a:prstGeom>
+          <a:noFill/>
+          <a:ln/>
+        </p:spPr>
+        <p:txBody>
+          <a:bodyPr wrap="square" lIns="0" tIns="0" rIns="0" bIns="0" rtlCol="0" anchor="ctr"/>
+          <a:lstStyle/>
+          <a:p>
+            <a:pPr algn="ctr" indent="0" marL="0">
+              <a:buNone/>
+            </a:pPr>
+            <a:r>
+              <a:rPr lang="en-US" sz="1300" b="1" dirty="0">
+                <a:solidFill>
+                  <a:schemeClr val="accent1"/>
+                </a:solidFill>
+              </a:rPr>
+              <a:t>Auto-matched</a:t>
+            </a:r>
+            <a:endParaRPr lang="en-US" sz="1400" dirty="0"/>
+          </a:p>
+          <a:p>
+            <a:pPr algn="ctr" indent="0" marL="0">
+              <a:buNone/>
+            </a:pPr>
+            <a:r>
+              <a:rPr lang="en-US" sz="1100" dirty="0">
+                <a:solidFill>
+                  <a:schemeClr val="tx1"/>
+                </a:solidFill>
+              </a:rPr>
+              <a:t>same email or reg. no.</a:t>
+            </a:r>
+            <a:endParaRPr lang="en-US" sz="1400" dirty="0"/>
+          </a:p>
+        </p:txBody>
+      </p:sp>
+      <p:sp>
+        <p:nvSpPr>
+          <p:cNvPr id="20" name="Shape 18"/>
           <p:cNvSpPr/>
           <p:nvPr/>
         </p:nvSpPr>
         <p:spPr>
           <a:xfrm>
-            <a:off x="3246120" y="1371600"/>
-            <a:ext cx="548640" cy="548640"/>
-          </a:xfrm>
-          <a:prstGeom prst="ellipse">
+            <a:off x="2468880" y="3401568"/>
+            <a:ext cx="1828800" cy="548640"/>
+          </a:xfrm>
+          <a:prstGeom prst="roundRect">
+            <a:avLst>
+              <a:gd name="adj" fmla="val 13333"/>
+            </a:avLst>
+          </a:prstGeom>
+          <a:solidFill>
+            <a:schemeClr val="bg2"/>
+          </a:solidFill>
+          <a:ln w="12700">
+            <a:solidFill>
+              <a:schemeClr val="bg2"/>
+            </a:solidFill>
+            <a:prstDash val="solid"/>
+          </a:ln>
+        </p:spPr>
+      </p:sp>
+      <p:sp>
+        <p:nvSpPr>
+          <p:cNvPr id="21" name="Text 19"/>
+          <p:cNvSpPr txBox="1"/>
+          <p:nvPr/>
+        </p:nvSpPr>
+        <p:spPr>
+          <a:xfrm>
+            <a:off x="2514600" y="3401568"/>
+            <a:ext cx="1737360" cy="548640"/>
+          </a:xfrm>
+          <a:prstGeom prst="rect">
+            <a:avLst/>
+          </a:prstGeom>
+          <a:noFill/>
+          <a:ln/>
+        </p:spPr>
+        <p:txBody>
+          <a:bodyPr wrap="square" lIns="0" tIns="0" rIns="0" bIns="0" rtlCol="0" anchor="ctr"/>
+          <a:lstStyle/>
+          <a:p>
+            <a:pPr algn="ctr" indent="0" marL="0">
+              <a:buNone/>
+            </a:pPr>
+            <a:r>
+              <a:rPr lang="en-US" sz="1300" b="1" dirty="0">
+                <a:solidFill>
+                  <a:schemeClr val="accent1"/>
+                </a:solidFill>
+              </a:rPr>
+              <a:t>To review</a:t>
+            </a:r>
+            <a:endParaRPr lang="en-US" sz="1400" dirty="0"/>
+          </a:p>
+          <a:p>
+            <a:pPr algn="ctr" indent="0" marL="0">
+              <a:buNone/>
+            </a:pPr>
+            <a:r>
+              <a:rPr lang="en-US" sz="1100" dirty="0">
+                <a:solidFill>
+                  <a:schemeClr val="tx1"/>
+                </a:solidFill>
+              </a:rPr>
+              <a:t>steward decides, 1 click</a:t>
+            </a:r>
+            <a:endParaRPr lang="en-US" sz="1400" dirty="0"/>
+          </a:p>
+        </p:txBody>
+      </p:sp>
+      <p:sp>
+        <p:nvSpPr>
+          <p:cNvPr id="22" name="Shape 20"/>
+          <p:cNvSpPr/>
+          <p:nvPr/>
+        </p:nvSpPr>
+        <p:spPr>
+          <a:xfrm>
+            <a:off x="4480560" y="3401568"/>
+            <a:ext cx="1828800" cy="548640"/>
+          </a:xfrm>
+          <a:prstGeom prst="roundRect">
+            <a:avLst>
+              <a:gd name="adj" fmla="val 13333"/>
+            </a:avLst>
+          </a:prstGeom>
+          <a:solidFill>
+            <a:schemeClr val="bg2"/>
+          </a:solidFill>
+          <a:ln w="12700">
+            <a:solidFill>
+              <a:schemeClr val="bg2"/>
+            </a:solidFill>
+            <a:prstDash val="solid"/>
+          </a:ln>
+        </p:spPr>
+      </p:sp>
+      <p:sp>
+        <p:nvSpPr>
+          <p:cNvPr id="23" name="Text 21"/>
+          <p:cNvSpPr txBox="1"/>
+          <p:nvPr/>
+        </p:nvSpPr>
+        <p:spPr>
+          <a:xfrm>
+            <a:off x="4526280" y="3401568"/>
+            <a:ext cx="1737360" cy="548640"/>
+          </a:xfrm>
+          <a:prstGeom prst="rect">
+            <a:avLst/>
+          </a:prstGeom>
+          <a:noFill/>
+          <a:ln/>
+        </p:spPr>
+        <p:txBody>
+          <a:bodyPr wrap="square" lIns="0" tIns="0" rIns="0" bIns="0" rtlCol="0" anchor="ctr"/>
+          <a:lstStyle/>
+          <a:p>
+            <a:pPr algn="ctr" indent="0" marL="0">
+              <a:buNone/>
+            </a:pPr>
+            <a:r>
+              <a:rPr lang="en-US" sz="1300" b="1" dirty="0">
+                <a:solidFill>
+                  <a:schemeClr val="accent1"/>
+                </a:solidFill>
+              </a:rPr>
+              <a:t>New HCP</a:t>
+            </a:r>
+            <a:endParaRPr lang="en-US" sz="1400" dirty="0"/>
+          </a:p>
+          <a:p>
+            <a:pPr algn="ctr" indent="0" marL="0">
+              <a:buNone/>
+            </a:pPr>
+            <a:r>
+              <a:rPr lang="en-US" sz="1100" dirty="0">
+                <a:solidFill>
+                  <a:schemeClr val="tx1"/>
+                </a:solidFill>
+              </a:rPr>
+              <a:t>no plausible candidate</a:t>
+            </a:r>
+            <a:endParaRPr lang="en-US" sz="1400" dirty="0"/>
+          </a:p>
+        </p:txBody>
+      </p:sp>
+      <p:sp>
+        <p:nvSpPr>
+          <p:cNvPr id="24" name="Shape 22"/>
+          <p:cNvSpPr/>
+          <p:nvPr/>
+        </p:nvSpPr>
+        <p:spPr>
+          <a:xfrm>
+            <a:off x="1371600" y="4041648"/>
+            <a:ext cx="6309360" cy="0"/>
+          </a:xfrm>
+          <a:prstGeom prst="line">
+            <a:avLst/>
+          </a:prstGeom>
+          <a:noFill/>
+          <a:ln w="15875">
+            <a:solidFill>
+              <a:schemeClr val="accent4"/>
+            </a:solidFill>
+            <a:prstDash val="solid"/>
+          </a:ln>
+        </p:spPr>
+      </p:sp>
+      <p:sp>
+        <p:nvSpPr>
+          <p:cNvPr id="25" name="Shape 23"/>
+          <p:cNvSpPr/>
+          <p:nvPr/>
+        </p:nvSpPr>
+        <p:spPr>
+          <a:xfrm>
+            <a:off x="3282696" y="4041648"/>
+            <a:ext cx="201168" cy="164592"/>
+          </a:xfrm>
+          <a:prstGeom prst="downArrow">
+            <a:avLst/>
+          </a:prstGeom>
+          <a:solidFill>
+            <a:schemeClr val="accent4"/>
+          </a:solidFill>
+          <a:ln w="12700">
+            <a:solidFill>
+              <a:schemeClr val="accent4"/>
+            </a:solidFill>
+            <a:prstDash val="solid"/>
+          </a:ln>
+        </p:spPr>
+      </p:sp>
+      <p:sp>
+        <p:nvSpPr>
+          <p:cNvPr id="26" name="Shape 24"/>
+          <p:cNvSpPr/>
+          <p:nvPr/>
+        </p:nvSpPr>
+        <p:spPr>
+          <a:xfrm>
+            <a:off x="7580376" y="4041648"/>
+            <a:ext cx="201168" cy="164592"/>
+          </a:xfrm>
+          <a:prstGeom prst="downArrow">
             <a:avLst/>
           </a:prstGeom>
           <a:solidFill>
@@ -2744,14 +3317,41 @@
       </p:sp>
       <p:sp>
         <p:nvSpPr>
-          <p:cNvPr id="11" name="Text 9"/>
+          <p:cNvPr id="27" name="Shape 25"/>
+          <p:cNvSpPr/>
+          <p:nvPr/>
+        </p:nvSpPr>
+        <p:spPr>
+          <a:xfrm>
+            <a:off x="2148840" y="4233672"/>
+            <a:ext cx="2468880" cy="502920"/>
+          </a:xfrm>
+          <a:prstGeom prst="roundRect">
+            <a:avLst>
+              <a:gd name="adj" fmla="val 14545"/>
+            </a:avLst>
+          </a:prstGeom>
+          <a:solidFill>
+            <a:srgbClr val="E3ECF7"/>
+          </a:solidFill>
+          <a:ln w="12700">
+            <a:solidFill>
+              <a:srgbClr val="E3ECF7"/>
+            </a:solidFill>
+            <a:prstDash val="solid"/>
+          </a:ln>
+        </p:spPr>
+      </p:sp>
+      <p:sp>
+        <p:nvSpPr>
+          <p:cNvPr id="28" name="Text 26"/>
           <p:cNvSpPr txBox="1"/>
           <p:nvPr/>
         </p:nvSpPr>
         <p:spPr>
           <a:xfrm>
-            <a:off x="3246120" y="1371600"/>
-            <a:ext cx="548640" cy="548640"/>
+            <a:off x="2194560" y="4233672"/>
+            <a:ext cx="2377440" cy="502920"/>
           </a:xfrm>
           <a:prstGeom prst="rect">
             <a:avLst/>
@@ -2767,99 +3367,41 @@
               <a:buNone/>
             </a:pPr>
             <a:r>
-              <a:rPr lang="en-US" sz="1600" b="1" dirty="0">
-                <a:solidFill>
-                  <a:schemeClr val="bg1"/>
-                </a:solidFill>
-              </a:rPr>
-              <a:t>2</a:t>
-            </a:r>
-            <a:endParaRPr lang="en-US" sz="1600" dirty="0"/>
-          </a:p>
-        </p:txBody>
-      </p:sp>
-      <p:sp>
-        <p:nvSpPr>
-          <p:cNvPr id="12" name="Text 10"/>
-          <p:cNvSpPr txBox="1"/>
-          <p:nvPr/>
-        </p:nvSpPr>
-        <p:spPr>
-          <a:xfrm>
-            <a:off x="2697480" y="2057400"/>
-            <a:ext cx="1645920" cy="411480"/>
-          </a:xfrm>
-          <a:prstGeom prst="rect">
-            <a:avLst/>
-          </a:prstGeom>
-          <a:noFill/>
-          <a:ln/>
-        </p:spPr>
-        <p:txBody>
-          <a:bodyPr wrap="square" lIns="0" tIns="0" rIns="0" bIns="0" rtlCol="0" anchor="t"/>
-          <a:lstStyle/>
+              <a:rPr lang="en-US" sz="1300" b="1" dirty="0">
+                <a:solidFill>
+                  <a:schemeClr val="accent1"/>
+                </a:solidFill>
+              </a:rPr>
+              <a:t>Consent record</a:t>
+            </a:r>
+            <a:endParaRPr lang="en-US" sz="1400" dirty="0"/>
+          </a:p>
           <a:p>
             <a:pPr algn="ctr" indent="0" marL="0">
               <a:buNone/>
             </a:pPr>
             <a:r>
-              <a:rPr lang="en-US" sz="1600" b="1" dirty="0">
-                <a:solidFill>
-                  <a:schemeClr val="accent1"/>
-                </a:solidFill>
-              </a:rPr>
-              <a:t>Capture</a:t>
-            </a:r>
-            <a:endParaRPr lang="en-US" sz="1600" dirty="0"/>
-          </a:p>
-        </p:txBody>
-      </p:sp>
-      <p:sp>
-        <p:nvSpPr>
-          <p:cNvPr id="13" name="Text 11"/>
-          <p:cNvSpPr txBox="1"/>
-          <p:nvPr/>
-        </p:nvSpPr>
-        <p:spPr>
-          <a:xfrm>
-            <a:off x="2743200" y="2514600"/>
-            <a:ext cx="1554480" cy="1143000"/>
-          </a:xfrm>
-          <a:prstGeom prst="rect">
-            <a:avLst/>
-          </a:prstGeom>
-          <a:noFill/>
-          <a:ln/>
-        </p:spPr>
-        <p:txBody>
-          <a:bodyPr wrap="square" lIns="0" tIns="0" rIns="0" bIns="0" rtlCol="0" anchor="t"/>
-          <a:lstStyle/>
-          <a:p>
-            <a:pPr algn="ctr" indent="0" marL="0">
-              <a:buNone/>
-            </a:pPr>
-            <a:r>
-              <a:rPr lang="en-US" sz="1200" dirty="0">
+              <a:rPr lang="en-US" sz="1100" dirty="0">
                 <a:solidFill>
                   <a:schemeClr val="tx1"/>
                 </a:solidFill>
               </a:rPr>
-              <a:t>HCP interaction recorded in Salesforce</a:t>
-            </a:r>
-            <a:endParaRPr lang="en-US" sz="1200" dirty="0"/>
-          </a:p>
-        </p:txBody>
-      </p:sp>
-      <p:sp>
-        <p:nvSpPr>
-          <p:cNvPr id="14" name="Shape 12"/>
+              <a:t>proof: text version, who, when, hash</a:t>
+            </a:r>
+            <a:endParaRPr lang="en-US" sz="1400" dirty="0"/>
+          </a:p>
+        </p:txBody>
+      </p:sp>
+      <p:sp>
+        <p:nvSpPr>
+          <p:cNvPr id="29" name="Shape 27"/>
           <p:cNvSpPr/>
           <p:nvPr/>
         </p:nvSpPr>
         <p:spPr>
           <a:xfrm>
-            <a:off x="4462272" y="2331720"/>
-            <a:ext cx="265176" cy="274320"/>
+            <a:off x="4681728" y="4343400"/>
+            <a:ext cx="274320" cy="274320"/>
           </a:xfrm>
           <a:prstGeom prst="rightArrow">
             <a:avLst/>
@@ -2877,18 +3419,18 @@
       </p:sp>
       <p:sp>
         <p:nvSpPr>
-          <p:cNvPr id="15" name="Shape 13"/>
+          <p:cNvPr id="30" name="Shape 28"/>
           <p:cNvSpPr/>
           <p:nvPr/>
         </p:nvSpPr>
         <p:spPr>
           <a:xfrm>
-            <a:off x="4754880" y="1188720"/>
-            <a:ext cx="1828800" cy="2560320"/>
+            <a:off x="5029200" y="4233672"/>
+            <a:ext cx="1600200" cy="502920"/>
           </a:xfrm>
           <a:prstGeom prst="roundRect">
             <a:avLst>
-              <a:gd name="adj" fmla="val 4000"/>
+              <a:gd name="adj" fmla="val 14545"/>
             </a:avLst>
           </a:prstGeom>
           <a:solidFill>
@@ -2904,176 +3446,68 @@
       </p:sp>
       <p:sp>
         <p:nvSpPr>
-          <p:cNvPr id="16" name="Shape 14"/>
+          <p:cNvPr id="31" name="Text 29"/>
+          <p:cNvSpPr txBox="1"/>
+          <p:nvPr/>
+        </p:nvSpPr>
+        <p:spPr>
+          <a:xfrm>
+            <a:off x="5074920" y="4233672"/>
+            <a:ext cx="1508760" cy="502920"/>
+          </a:xfrm>
+          <a:prstGeom prst="rect">
+            <a:avLst/>
+          </a:prstGeom>
+          <a:noFill/>
+          <a:ln/>
+        </p:spPr>
+        <p:txBody>
+          <a:bodyPr wrap="square" lIns="0" tIns="0" rIns="0" bIns="0" rtlCol="0" anchor="ctr"/>
+          <a:lstStyle/>
+          <a:p>
+            <a:pPr algn="ctr" indent="0" marL="0">
+              <a:buNone/>
+            </a:pPr>
+            <a:r>
+              <a:rPr lang="en-US" sz="1300" b="1" dirty="0">
+                <a:solidFill>
+                  <a:schemeClr val="accent1"/>
+                </a:solidFill>
+              </a:rPr>
+              <a:t>Sent to Gigya</a:t>
+            </a:r>
+            <a:endParaRPr lang="en-US" sz="1400" dirty="0"/>
+          </a:p>
+          <a:p>
+            <a:pPr algn="ctr" indent="0" marL="0">
+              <a:buNone/>
+            </a:pPr>
+            <a:r>
+              <a:rPr lang="en-US" sz="1100" dirty="0">
+                <a:solidFill>
+                  <a:schemeClr val="tx1"/>
+                </a:solidFill>
+              </a:rPr>
+              <a:t>marketing can communicate</a:t>
+            </a:r>
+            <a:endParaRPr lang="en-US" sz="1400" dirty="0"/>
+          </a:p>
+        </p:txBody>
+      </p:sp>
+      <p:sp>
+        <p:nvSpPr>
+          <p:cNvPr id="32" name="Shape 30"/>
           <p:cNvSpPr/>
           <p:nvPr/>
         </p:nvSpPr>
         <p:spPr>
           <a:xfrm>
-            <a:off x="5394960" y="1371600"/>
-            <a:ext cx="548640" cy="548640"/>
-          </a:xfrm>
-          <a:prstGeom prst="ellipse">
-            <a:avLst/>
-          </a:prstGeom>
-          <a:solidFill>
-            <a:schemeClr val="accent2"/>
-          </a:solidFill>
-          <a:ln w="12700">
-            <a:solidFill>
-              <a:schemeClr val="accent2"/>
-            </a:solidFill>
-            <a:prstDash val="solid"/>
-          </a:ln>
-        </p:spPr>
-      </p:sp>
-      <p:sp>
-        <p:nvSpPr>
-          <p:cNvPr id="17" name="Text 15"/>
-          <p:cNvSpPr txBox="1"/>
-          <p:nvPr/>
-        </p:nvSpPr>
-        <p:spPr>
-          <a:xfrm>
-            <a:off x="5394960" y="1371600"/>
-            <a:ext cx="548640" cy="548640"/>
-          </a:xfrm>
-          <a:prstGeom prst="rect">
-            <a:avLst/>
-          </a:prstGeom>
-          <a:noFill/>
-          <a:ln/>
-        </p:spPr>
-        <p:txBody>
-          <a:bodyPr wrap="square" lIns="0" tIns="0" rIns="0" bIns="0" rtlCol="0" anchor="ctr"/>
-          <a:lstStyle/>
-          <a:p>
-            <a:pPr algn="ctr" indent="0" marL="0">
-              <a:buNone/>
-            </a:pPr>
-            <a:r>
-              <a:rPr lang="en-US" sz="1600" b="1" dirty="0">
-                <a:solidFill>
-                  <a:schemeClr val="bg1"/>
-                </a:solidFill>
-              </a:rPr>
-              <a:t>3</a:t>
-            </a:r>
-            <a:endParaRPr lang="en-US" sz="1600" dirty="0"/>
-          </a:p>
-        </p:txBody>
-      </p:sp>
-      <p:sp>
-        <p:nvSpPr>
-          <p:cNvPr id="18" name="Text 16"/>
-          <p:cNvSpPr txBox="1"/>
-          <p:nvPr/>
-        </p:nvSpPr>
-        <p:spPr>
-          <a:xfrm>
-            <a:off x="4846320" y="2057400"/>
-            <a:ext cx="1645920" cy="411480"/>
-          </a:xfrm>
-          <a:prstGeom prst="rect">
-            <a:avLst/>
-          </a:prstGeom>
-          <a:noFill/>
-          <a:ln/>
-        </p:spPr>
-        <p:txBody>
-          <a:bodyPr wrap="square" lIns="0" tIns="0" rIns="0" bIns="0" rtlCol="0" anchor="t"/>
-          <a:lstStyle/>
-          <a:p>
-            <a:pPr algn="ctr" indent="0" marL="0">
-              <a:buNone/>
-            </a:pPr>
-            <a:r>
-              <a:rPr lang="en-US" sz="1600" b="1" dirty="0">
-                <a:solidFill>
-                  <a:schemeClr val="accent1"/>
-                </a:solidFill>
-              </a:rPr>
-              <a:t>Matching</a:t>
-            </a:r>
-            <a:endParaRPr lang="en-US" sz="1600" dirty="0"/>
-          </a:p>
-        </p:txBody>
-      </p:sp>
-      <p:sp>
-        <p:nvSpPr>
-          <p:cNvPr id="19" name="Text 17"/>
-          <p:cNvSpPr txBox="1"/>
-          <p:nvPr/>
-        </p:nvSpPr>
-        <p:spPr>
-          <a:xfrm>
-            <a:off x="4892040" y="2514600"/>
-            <a:ext cx="1554480" cy="1143000"/>
-          </a:xfrm>
-          <a:prstGeom prst="rect">
-            <a:avLst/>
-          </a:prstGeom>
-          <a:noFill/>
-          <a:ln/>
-        </p:spPr>
-        <p:txBody>
-          <a:bodyPr wrap="square" lIns="0" tIns="0" rIns="0" bIns="0" rtlCol="0" anchor="t"/>
-          <a:lstStyle/>
-          <a:p>
-            <a:pPr algn="ctr" indent="0" marL="0">
-              <a:buNone/>
-            </a:pPr>
-            <a:r>
-              <a:rPr lang="en-US" sz="1200" dirty="0">
-                <a:solidFill>
-                  <a:schemeClr val="tx1"/>
-                </a:solidFill>
-              </a:rPr>
-              <a:t>Capture linked to the right HCP record</a:t>
-            </a:r>
-            <a:endParaRPr lang="en-US" sz="1200" dirty="0"/>
-          </a:p>
-        </p:txBody>
-      </p:sp>
-      <p:sp>
-        <p:nvSpPr>
-          <p:cNvPr id="20" name="Shape 18"/>
-          <p:cNvSpPr/>
-          <p:nvPr/>
-        </p:nvSpPr>
-        <p:spPr>
-          <a:xfrm>
-            <a:off x="6611112" y="2331720"/>
-            <a:ext cx="265176" cy="274320"/>
-          </a:xfrm>
-          <a:prstGeom prst="rightArrow">
-            <a:avLst/>
-          </a:prstGeom>
-          <a:solidFill>
-            <a:schemeClr val="accent4"/>
-          </a:solidFill>
-          <a:ln w="12700">
-            <a:solidFill>
-              <a:schemeClr val="accent4"/>
-            </a:solidFill>
-            <a:prstDash val="solid"/>
-          </a:ln>
-        </p:spPr>
-      </p:sp>
-      <p:sp>
-        <p:nvSpPr>
-          <p:cNvPr id="21" name="Shape 19"/>
-          <p:cNvSpPr/>
-          <p:nvPr/>
-        </p:nvSpPr>
-        <p:spPr>
-          <a:xfrm>
-            <a:off x="6903720" y="1188720"/>
-            <a:ext cx="1828800" cy="2560320"/>
+            <a:off x="6720840" y="4233672"/>
+            <a:ext cx="1828800" cy="502920"/>
           </a:xfrm>
           <a:prstGeom prst="roundRect">
             <a:avLst>
-              <a:gd name="adj" fmla="val 4000"/>
+              <a:gd name="adj" fmla="val 14545"/>
             </a:avLst>
           </a:prstGeom>
           <a:solidFill>
@@ -3089,24 +3523,76 @@
       </p:sp>
       <p:sp>
         <p:nvSpPr>
-          <p:cNvPr id="22" name="Shape 20"/>
+          <p:cNvPr id="33" name="Text 31"/>
+          <p:cNvSpPr txBox="1"/>
+          <p:nvPr/>
+        </p:nvSpPr>
+        <p:spPr>
+          <a:xfrm>
+            <a:off x="6766560" y="4233672"/>
+            <a:ext cx="1737360" cy="502920"/>
+          </a:xfrm>
+          <a:prstGeom prst="rect">
+            <a:avLst/>
+          </a:prstGeom>
+          <a:noFill/>
+          <a:ln/>
+        </p:spPr>
+        <p:txBody>
+          <a:bodyPr wrap="square" lIns="0" tIns="0" rIns="0" bIns="0" rtlCol="0" anchor="ctr"/>
+          <a:lstStyle/>
+          <a:p>
+            <a:pPr algn="ctr" indent="0" marL="0">
+              <a:buNone/>
+            </a:pPr>
+            <a:r>
+              <a:rPr lang="en-US" sz="1300" b="1" dirty="0">
+                <a:solidFill>
+                  <a:schemeClr val="accent2"/>
+                </a:solidFill>
+              </a:rPr>
+              <a:t>Visit</a:t>
+            </a:r>
+            <a:endParaRPr lang="en-US" sz="1400" dirty="0"/>
+          </a:p>
+          <a:p>
+            <a:pPr algn="ctr" indent="0" marL="0">
+              <a:buNone/>
+            </a:pPr>
+            <a:r>
+              <a:rPr lang="en-US" sz="1100" dirty="0">
+                <a:solidFill>
+                  <a:schemeClr val="tx1"/>
+                </a:solidFill>
+              </a:rPr>
+              <a:t>created by Apex on the HCP</a:t>
+            </a:r>
+            <a:endParaRPr lang="en-US" sz="1400" dirty="0"/>
+          </a:p>
+        </p:txBody>
+      </p:sp>
+      <p:sp>
+        <p:nvSpPr>
+          <p:cNvPr id="34" name="Shape 32"/>
           <p:cNvSpPr/>
           <p:nvPr/>
         </p:nvSpPr>
         <p:spPr>
           <a:xfrm>
-            <a:off x="7543800" y="1371600"/>
-            <a:ext cx="548640" cy="548640"/>
-          </a:xfrm>
-          <a:prstGeom prst="ellipse">
-            <a:avLst/>
+            <a:off x="6720840" y="1005840"/>
+            <a:ext cx="1965960" cy="2743200"/>
+          </a:xfrm>
+          <a:prstGeom prst="roundRect">
+            <a:avLst>
+              <a:gd name="adj" fmla="val 3721"/>
+            </a:avLst>
           </a:prstGeom>
           <a:solidFill>
-            <a:schemeClr val="accent2"/>
+            <a:schemeClr val="bg2"/>
           </a:solidFill>
           <a:ln w="12700">
             <a:solidFill>
-              <a:schemeClr val="accent2"/>
+              <a:schemeClr val="bg2"/>
             </a:solidFill>
             <a:prstDash val="solid"/>
           </a:ln>
@@ -3114,50 +3600,61 @@
       </p:sp>
       <p:sp>
         <p:nvSpPr>
-          <p:cNvPr id="23" name="Text 21"/>
+          <p:cNvPr id="35" name="Text 33"/>
           <p:cNvSpPr txBox="1"/>
           <p:nvPr/>
         </p:nvSpPr>
         <p:spPr>
           <a:xfrm>
-            <a:off x="7543800" y="1371600"/>
-            <a:ext cx="548640" cy="548640"/>
-          </a:xfrm>
-          <a:prstGeom prst="rect">
-            <a:avLst/>
-          </a:prstGeom>
-          <a:noFill/>
-          <a:ln/>
-        </p:spPr>
-        <p:txBody>
-          <a:bodyPr wrap="square" lIns="0" tIns="0" rIns="0" bIns="0" rtlCol="0" anchor="ctr"/>
-          <a:lstStyle/>
-          <a:p>
-            <a:pPr algn="ctr" indent="0" marL="0">
-              <a:buNone/>
-            </a:pPr>
-            <a:r>
-              <a:rPr lang="en-US" sz="1600" b="1" dirty="0">
-                <a:solidFill>
-                  <a:schemeClr val="bg1"/>
-                </a:solidFill>
-              </a:rPr>
-              <a:t>4</a:t>
-            </a:r>
-            <a:endParaRPr lang="en-US" sz="1600" dirty="0"/>
-          </a:p>
-        </p:txBody>
-      </p:sp>
-      <p:sp>
-        <p:nvSpPr>
-          <p:cNvPr id="24" name="Text 22"/>
+            <a:off x="6858000" y="1143000"/>
+            <a:ext cx="1691640" cy="731520"/>
+          </a:xfrm>
+          <a:prstGeom prst="rect">
+            <a:avLst/>
+          </a:prstGeom>
+          <a:noFill/>
+          <a:ln/>
+        </p:spPr>
+        <p:txBody>
+          <a:bodyPr wrap="square" lIns="0" tIns="0" rIns="0" bIns="0" rtlCol="0" anchor="t"/>
+          <a:lstStyle/>
+          <a:p>
+            <a:pPr indent="0" marL="0">
+              <a:buNone/>
+            </a:pPr>
+            <a:r>
+              <a:rPr lang="en-US" sz="1200" b="1" dirty="0">
+                <a:solidFill>
+                  <a:schemeClr val="accent3"/>
+                </a:solidFill>
+              </a:rPr>
+              <a:t>Existing: </a:t>
+            </a:r>
+            <a:pPr indent="0" marL="0">
+              <a:buNone/>
+            </a:pPr>
+            <a:r>
+              <a:rPr lang="en-US" sz="1200" dirty="0">
+                <a:solidFill>
+                  <a:schemeClr val="tx1"/>
+                </a:solidFill>
+              </a:rPr>
+              <a:t>Congress and attendees (Pitcher)</a:t>
+            </a:r>
+            <a:endParaRPr lang="en-US" sz="1200" dirty="0"/>
+          </a:p>
+        </p:txBody>
+      </p:sp>
+      <p:sp>
+        <p:nvSpPr>
+          <p:cNvPr id="36" name="Text 34"/>
           <p:cNvSpPr txBox="1"/>
           <p:nvPr/>
         </p:nvSpPr>
         <p:spPr>
           <a:xfrm>
-            <a:off x="6995160" y="2057400"/>
-            <a:ext cx="1645920" cy="411480"/>
+            <a:off x="6858000" y="1920240"/>
+            <a:ext cx="1691640" cy="914400"/>
           </a:xfrm>
           <a:prstGeom prst="rect">
             <a:avLst/>
@@ -3169,31 +3666,42 @@
           <a:bodyPr wrap="square" lIns="0" tIns="0" rIns="0" bIns="0" rtlCol="0" anchor="t"/>
           <a:lstStyle/>
           <a:p>
-            <a:pPr algn="ctr" indent="0" marL="0">
-              <a:buNone/>
-            </a:pPr>
-            <a:r>
-              <a:rPr lang="en-US" sz="1600" b="1" dirty="0">
-                <a:solidFill>
-                  <a:schemeClr val="accent1"/>
-                </a:solidFill>
-              </a:rPr>
-              <a:t>Visit</a:t>
-            </a:r>
-            <a:endParaRPr lang="en-US" sz="1600" dirty="0"/>
-          </a:p>
-        </p:txBody>
-      </p:sp>
-      <p:sp>
-        <p:nvSpPr>
-          <p:cNvPr id="25" name="Text 23"/>
+            <a:pPr indent="0" marL="0">
+              <a:buNone/>
+            </a:pPr>
+            <a:r>
+              <a:rPr lang="en-US" sz="1200" b="1" dirty="0">
+                <a:solidFill>
+                  <a:schemeClr val="accent2"/>
+                </a:solidFill>
+              </a:rPr>
+              <a:t>New: </a:t>
+            </a:r>
+            <a:pPr indent="0" marL="0">
+              <a:buNone/>
+            </a:pPr>
+            <a:r>
+              <a:rPr lang="en-US" sz="1200" dirty="0">
+                <a:solidFill>
+                  <a:schemeClr val="tx1"/>
+                </a:solidFill>
+              </a:rPr>
+              <a:t>Capture, matching, consent and Visit, in Salesforce from the browser</a:t>
+            </a:r>
+            <a:endParaRPr lang="en-US" sz="1200" dirty="0"/>
+          </a:p>
+        </p:txBody>
+      </p:sp>
+      <p:sp>
+        <p:nvSpPr>
+          <p:cNvPr id="37" name="Text 35"/>
           <p:cNvSpPr txBox="1"/>
           <p:nvPr/>
         </p:nvSpPr>
         <p:spPr>
           <a:xfrm>
-            <a:off x="7040880" y="2514600"/>
-            <a:ext cx="1554480" cy="1143000"/>
+            <a:off x="6858000" y="2926080"/>
+            <a:ext cx="1691640" cy="731520"/>
           </a:xfrm>
           <a:prstGeom prst="rect">
             <a:avLst/>
@@ -3205,7 +3713,18 @@
           <a:bodyPr wrap="square" lIns="0" tIns="0" rIns="0" bIns="0" rtlCol="0" anchor="t"/>
           <a:lstStyle/>
           <a:p>
-            <a:pPr algn="ctr" indent="0" marL="0">
+            <a:pPr indent="0" marL="0">
+              <a:buNone/>
+            </a:pPr>
+            <a:r>
+              <a:rPr lang="en-US" sz="1200" b="1" dirty="0">
+                <a:solidFill>
+                  <a:schemeClr val="accent2"/>
+                </a:solidFill>
+              </a:rPr>
+              <a:t>Visit </a:t>
+            </a:r>
+            <a:pPr indent="0" marL="0">
               <a:buNone/>
             </a:pPr>
             <a:r>
@@ -3214,78 +3733,9 @@
                   <a:schemeClr val="tx1"/>
                 </a:solidFill>
               </a:rPr>
-              <a:t>Presentation created by Apex on the HCP</a:t>
+              <a:t>only once the HCP is known</a:t>
             </a:r>
             <a:endParaRPr lang="en-US" sz="1200" dirty="0"/>
-          </a:p>
-        </p:txBody>
-      </p:sp>
-      <p:sp>
-        <p:nvSpPr>
-          <p:cNvPr id="26" name="Text 24"/>
-          <p:cNvSpPr txBox="1"/>
-          <p:nvPr/>
-        </p:nvSpPr>
-        <p:spPr>
-          <a:xfrm>
-            <a:off x="457200" y="4023360"/>
-            <a:ext cx="8229600" cy="365760"/>
-          </a:xfrm>
-          <a:prstGeom prst="rect">
-            <a:avLst/>
-          </a:prstGeom>
-          <a:noFill/>
-          <a:ln/>
-        </p:spPr>
-        <p:txBody>
-          <a:bodyPr wrap="square" lIns="0" tIns="0" rIns="0" bIns="0" rtlCol="0" anchor="t"/>
-          <a:lstStyle/>
-          <a:p>
-            <a:pPr indent="0" marL="0">
-              <a:buNone/>
-            </a:pPr>
-            <a:r>
-              <a:rPr lang="en-US" sz="1400" b="1" dirty="0">
-                <a:solidFill>
-                  <a:schemeClr val="accent3"/>
-                </a:solidFill>
-              </a:rPr>
-              <a:t>Existing: </a:t>
-            </a:r>
-            <a:pPr indent="0" marL="0">
-              <a:buNone/>
-            </a:pPr>
-            <a:r>
-              <a:rPr lang="en-US" sz="1400" dirty="0">
-                <a:solidFill>
-                  <a:schemeClr val="tx1"/>
-                </a:solidFill>
-              </a:rPr>
-              <a:t>Congress and attendees (Pitcher)     </a:t>
-            </a:r>
-            <a:pPr indent="0" marL="0">
-              <a:buNone/>
-            </a:pPr>
-            <a:r>
-              <a:rPr lang="en-US" sz="1400" b="1" dirty="0">
-                <a:solidFill>
-                  <a:schemeClr val="accent2"/>
-                </a:solidFill>
-              </a:rPr>
-              <a:t>New: </a:t>
-            </a:r>
-            <a:pPr indent="0" marL="0">
-              <a:buNone/>
-            </a:pPr>
-            <a:r>
-              <a:rPr lang="en-US" sz="1400" dirty="0">
-                <a:solidFill>
-                  <a:schemeClr val="tx1"/>
-                </a:solidFill>
-              </a:rPr>
-              <a:t>Capture, matching and Visit, in Salesforce from the browser</a:t>
-            </a:r>
-            <a:endParaRPr lang="en-US" sz="1400" dirty="0"/>
           </a:p>
         </p:txBody>
       </p:sp>
@@ -4481,11 +4931,11 @@
             </a:avLst>
           </a:prstGeom>
           <a:solidFill>
-            <a:srgbClr val="E3ECF7"/>
+            <a:srgbClr val="FBE3DC"/>
           </a:solidFill>
           <a:ln w="12700">
             <a:solidFill>
-              <a:srgbClr val="E3ECF7"/>
+              <a:srgbClr val="FBE3DC"/>
             </a:solidFill>
             <a:prstDash val="solid"/>
           </a:ln>
@@ -4518,7 +4968,7 @@
             <a:r>
               <a:rPr lang="en-US" sz="1500" b="1" dirty="0">
                 <a:solidFill>
-                  <a:schemeClr val="accent1"/>
+                  <a:schemeClr val="accent2"/>
                 </a:solidFill>
               </a:rPr>
               <a:t>Consent</a:t>
@@ -4557,7 +5007,7 @@
                   <a:schemeClr val="accent4"/>
                 </a:solidFill>
               </a:rPr>
-              <a:t>Valid after email Confirm or signature</a:t>
+              <a:t>New</a:t>
             </a:r>
             <a:endParaRPr lang="en-US" sz="1100" dirty="0"/>
           </a:p>
@@ -4593,7 +5043,7 @@
                   <a:schemeClr val="tx1"/>
                 </a:solidFill>
               </a:rPr>
-              <a:t>Proof: text version, who, when, hash. Sent to Gigya</a:t>
+              <a:t>HCP, status, text version, who, when, hash. Valid after email Confirm or signature, sent to Gigya</a:t>
             </a:r>
             <a:endParaRPr lang="en-US" sz="1200" dirty="0"/>
           </a:p>
@@ -4728,7 +5178,7 @@
                   <a:schemeClr val="tx1"/>
                 </a:solidFill>
               </a:rPr>
-              <a:t>Matched HCP, holds consent and activity history</a:t>
+              <a:t>Matched HCP record</a:t>
             </a:r>
             <a:endParaRPr lang="en-US" sz="1200" dirty="0"/>
           </a:p>
@@ -4827,7 +5277,7 @@
                   <a:schemeClr val="accent4"/>
                 </a:solidFill>
               </a:rPr>
-              <a:t>Existing</a:t>
+              <a:t>Existing - type Congress / Training</a:t>
             </a:r>
             <a:endParaRPr lang="en-US" sz="1100" dirty="0"/>
           </a:p>
@@ -4951,6 +5401,66 @@
           <p:nvPr/>
         </p:nvSpPr>
         <p:spPr>
+          <a:xfrm flipH="1">
+            <a:off x="2743200" y="2606040"/>
+            <a:ext cx="3566160" cy="411480"/>
+          </a:xfrm>
+          <a:prstGeom prst="line">
+            <a:avLst/>
+          </a:prstGeom>
+          <a:noFill/>
+          <a:ln w="25400">
+            <a:solidFill>
+              <a:schemeClr val="accent2"/>
+            </a:solidFill>
+            <a:prstDash val="solid"/>
+            <a:tailEnd type="triangle"/>
+          </a:ln>
+        </p:spPr>
+      </p:sp>
+      <p:sp>
+        <p:nvSpPr>
+          <p:cNvPr id="31" name="Text 29"/>
+          <p:cNvSpPr txBox="1"/>
+          <p:nvPr/>
+        </p:nvSpPr>
+        <p:spPr>
+          <a:xfrm>
+            <a:off x="3931920" y="2487168"/>
+            <a:ext cx="1188720" cy="274320"/>
+          </a:xfrm>
+          <a:prstGeom prst="rect">
+            <a:avLst/>
+          </a:prstGeom>
+          <a:noFill/>
+          <a:ln/>
+        </p:spPr>
+        <p:txBody>
+          <a:bodyPr wrap="square" lIns="0" tIns="0" rIns="0" bIns="0" rtlCol="0" anchor="t"/>
+          <a:lstStyle/>
+          <a:p>
+            <a:pPr algn="ctr" indent="0" marL="0">
+              <a:buNone/>
+            </a:pPr>
+            <a:r>
+              <a:rPr lang="en-US" sz="1100" i="1" dirty="0">
+                <a:solidFill>
+                  <a:schemeClr val="accent2"/>
+                </a:solidFill>
+              </a:rPr>
+              <a:t>after match</a:t>
+            </a:r>
+            <a:endParaRPr lang="en-US" sz="1100" dirty="0"/>
+          </a:p>
+        </p:txBody>
+      </p:sp>
+      <p:sp>
+        <p:nvSpPr>
+          <p:cNvPr id="32" name="Shape 30"/>
+          <p:cNvSpPr/>
+          <p:nvPr/>
+        </p:nvSpPr>
+        <p:spPr>
           <a:xfrm>
             <a:off x="2971800" y="3657600"/>
             <a:ext cx="320040" cy="274320"/>
@@ -4971,7 +5481,7 @@
       </p:sp>
       <p:sp>
         <p:nvSpPr>
-          <p:cNvPr id="31" name="Shape 29"/>
+          <p:cNvPr id="33" name="Shape 31"/>
           <p:cNvSpPr/>
           <p:nvPr/>
         </p:nvSpPr>
@@ -4996,7 +5506,7 @@
       </p:sp>
       <p:sp>
         <p:nvSpPr>
-          <p:cNvPr id="32" name="Text 30"/>
+          <p:cNvPr id="34" name="Text 32"/>
           <p:cNvSpPr txBox="1"/>
           <p:nvPr/>
         </p:nvSpPr>

</xml_diff>

<commit_message>
Final Congress deck: aligned data model, consent update flow, no duplicate next-steps divider
Co-Authored-By: Claude Opus 5.5 <noreply@anthropic.com>
Claude-Session: https://claude.ai/code/session_01UEyZwgtPKErqguEM4x8Yck
</commit_message>
<xml_diff>
--- a/slides/France_CBU_Congress_Solution.pptx
+++ b/slides/France_CBU_Congress_Solution.pptx
@@ -115,30 +115,30 @@
   <p:extLst>
     <p:ext uri="{521415D9-36F7-43E2-AB2F-B90AF26B5E84}">
       <p14:sectionLst xmlns:p14="http://schemas.microsoft.com/office/powerpoint/2010/main">
-        <p14:section name="Intro" id="{ff3d981e-cc07-0ee1-305f-b98b99ad2236}">
+        <p14:section name="Intro" id="{31f0a1ae-00ed-28ad-95c7-90fb2d95b0f4}">
           <p14:sldIdLst>
             <p14:sldId id="256"/>
           </p14:sldIdLst>
         </p14:section>
-        <p14:section name="Context" id="{7e55843f-f7e5-9d3d-a108-f98c400d4e5e}">
+        <p14:section name="Context" id="{365edfe6-73ba-7547-d500-ae5c72917b1f}">
           <p14:sldIdLst>
             <p14:sldId id="257"/>
           </p14:sldIdLst>
         </p14:section>
-        <p14:section name="Solution" id="{6320d282-b5cf-b34d-120a-c8eb5d67348d}">
+        <p14:section name="Solution" id="{676cebe4-a96c-0d1f-5a9f-afdd1c1f8627}">
           <p14:sldIdLst>
             <p14:sldId id="258"/>
             <p14:sldId id="259"/>
             <p14:sldId id="260"/>
           </p14:sldIdLst>
         </p14:section>
-        <p14:section name="Visit" id="{0eb53bcc-72ed-b63e-b967-9defac5fdc33}">
+        <p14:section name="Visit" id="{c1efcf96-a416-e572-e5c4-1677bfb44e34}">
           <p14:sldIdLst>
             <p14:sldId id="261"/>
             <p14:sldId id="262"/>
           </p14:sldIdLst>
         </p14:section>
-        <p14:section name="Next steps" id="{2b2133fd-37a0-c896-05d7-fed0ce6d3a31}">
+        <p14:section name="Next steps" id="{1cf7b3bb-240c-479e-d854-b4e48c67ac4f}">
           <p14:sldIdLst>
             <p14:sldId id="263"/>
             <p14:sldId id="264"/>
@@ -724,7 +724,7 @@
           <a:p>
             <a:r>
               <a:rPr lang="en-US" dirty="0"/>
-              <a:t>Three channels feed one Capture. Matching links it to the right HCP record (auto-match, steward review or new HCP). Then the consent record is created and sent to Gigya, and Apex creates the Visit on the HCP.</a:t>
+              <a:t>Three channels feed one Capture. Matching links it to the right HCP record (auto-match, steward review or new HCP). Then the consent record is updated and sent to Gigya, and Apex creates the Visit on the HCP.</a:t>
             </a:r>
             <a:endParaRPr lang="en-US" dirty="0"/>
           </a:p>
@@ -2513,12 +2513,12 @@
         </p:nvSpPr>
         <p:spPr>
           <a:xfrm>
-            <a:off x="457200" y="1005840"/>
-            <a:ext cx="1828800" cy="548640"/>
+            <a:off x="457200" y="1051560"/>
+            <a:ext cx="1828800" cy="566928"/>
           </a:xfrm>
           <a:prstGeom prst="roundRect">
             <a:avLst>
-              <a:gd name="adj" fmla="val 13333"/>
+              <a:gd name="adj" fmla="val 12903"/>
             </a:avLst>
           </a:prstGeom>
           <a:solidFill>
@@ -2540,8 +2540,8 @@
         </p:nvSpPr>
         <p:spPr>
           <a:xfrm>
-            <a:off x="502920" y="1005840"/>
-            <a:ext cx="1737360" cy="548640"/>
+            <a:off x="502920" y="1051560"/>
+            <a:ext cx="1737360" cy="566928"/>
           </a:xfrm>
           <a:prstGeom prst="rect">
             <a:avLst/>
@@ -2590,12 +2590,12 @@
         </p:nvSpPr>
         <p:spPr>
           <a:xfrm>
-            <a:off x="2468880" y="1005840"/>
-            <a:ext cx="1828800" cy="548640"/>
+            <a:off x="2468880" y="1051560"/>
+            <a:ext cx="1828800" cy="566928"/>
           </a:xfrm>
           <a:prstGeom prst="roundRect">
             <a:avLst>
-              <a:gd name="adj" fmla="val 13333"/>
+              <a:gd name="adj" fmla="val 12903"/>
             </a:avLst>
           </a:prstGeom>
           <a:solidFill>
@@ -2617,8 +2617,8 @@
         </p:nvSpPr>
         <p:spPr>
           <a:xfrm>
-            <a:off x="2514600" y="1005840"/>
-            <a:ext cx="1737360" cy="548640"/>
+            <a:off x="2514600" y="1051560"/>
+            <a:ext cx="1737360" cy="566928"/>
           </a:xfrm>
           <a:prstGeom prst="rect">
             <a:avLst/>
@@ -2667,12 +2667,12 @@
         </p:nvSpPr>
         <p:spPr>
           <a:xfrm>
-            <a:off x="4480560" y="1005840"/>
-            <a:ext cx="1828800" cy="548640"/>
+            <a:off x="4480560" y="1051560"/>
+            <a:ext cx="1828800" cy="566928"/>
           </a:xfrm>
           <a:prstGeom prst="roundRect">
             <a:avLst>
-              <a:gd name="adj" fmla="val 13333"/>
+              <a:gd name="adj" fmla="val 12903"/>
             </a:avLst>
           </a:prstGeom>
           <a:solidFill>
@@ -2694,8 +2694,8 @@
         </p:nvSpPr>
         <p:spPr>
           <a:xfrm>
-            <a:off x="4526280" y="1005840"/>
-            <a:ext cx="1737360" cy="548640"/>
+            <a:off x="4526280" y="1051560"/>
+            <a:ext cx="1737360" cy="566928"/>
           </a:xfrm>
           <a:prstGeom prst="rect">
             <a:avLst/>
@@ -2744,7 +2744,7 @@
         </p:nvSpPr>
         <p:spPr>
           <a:xfrm>
-            <a:off x="1371600" y="1664208"/>
+            <a:off x="1371600" y="1783080"/>
             <a:ext cx="4023360" cy="0"/>
           </a:xfrm>
           <a:prstGeom prst="line">
@@ -2767,8 +2767,8 @@
         </p:nvSpPr>
         <p:spPr>
           <a:xfrm>
-            <a:off x="3282696" y="1664208"/>
-            <a:ext cx="201168" cy="182880"/>
+            <a:off x="3282696" y="1783080"/>
+            <a:ext cx="201168" cy="201168"/>
           </a:xfrm>
           <a:prstGeom prst="downArrow">
             <a:avLst/>
@@ -2792,12 +2792,12 @@
         </p:nvSpPr>
         <p:spPr>
           <a:xfrm>
-            <a:off x="2377440" y="1874520"/>
-            <a:ext cx="2011680" cy="548640"/>
+            <a:off x="2377440" y="2057400"/>
+            <a:ext cx="2011680" cy="566928"/>
           </a:xfrm>
           <a:prstGeom prst="roundRect">
             <a:avLst>
-              <a:gd name="adj" fmla="val 13333"/>
+              <a:gd name="adj" fmla="val 12903"/>
             </a:avLst>
           </a:prstGeom>
           <a:solidFill>
@@ -2819,8 +2819,8 @@
         </p:nvSpPr>
         <p:spPr>
           <a:xfrm>
-            <a:off x="2423160" y="1874520"/>
-            <a:ext cx="1920240" cy="548640"/>
+            <a:off x="2423160" y="2057400"/>
+            <a:ext cx="1920240" cy="566928"/>
           </a:xfrm>
           <a:prstGeom prst="rect">
             <a:avLst/>
@@ -2869,8 +2869,8 @@
         </p:nvSpPr>
         <p:spPr>
           <a:xfrm>
-            <a:off x="3282696" y="2441448"/>
-            <a:ext cx="201168" cy="164592"/>
+            <a:off x="3282696" y="2651760"/>
+            <a:ext cx="201168" cy="201168"/>
           </a:xfrm>
           <a:prstGeom prst="downArrow">
             <a:avLst/>
@@ -2888,18 +2888,635 @@
       </p:sp>
       <p:sp>
         <p:nvSpPr>
-          <p:cNvPr id="14" name="Shape 12"/>
+          <p:cNvPr id="14" name="Text 12"/>
+          <p:cNvSpPr txBox="1"/>
+          <p:nvPr/>
+        </p:nvSpPr>
+        <p:spPr>
+          <a:xfrm>
+            <a:off x="3566160" y="2633472"/>
+            <a:ext cx="1645920" cy="256032"/>
+          </a:xfrm>
+          <a:prstGeom prst="rect">
+            <a:avLst/>
+          </a:prstGeom>
+          <a:noFill/>
+          <a:ln/>
+        </p:spPr>
+        <p:txBody>
+          <a:bodyPr wrap="square" lIns="0" tIns="0" rIns="0" bIns="0" rtlCol="0" anchor="t"/>
+          <a:lstStyle/>
+          <a:p>
+            <a:pPr indent="0" marL="0">
+              <a:buNone/>
+            </a:pPr>
+            <a:r>
+              <a:rPr lang="en-US" sz="1100" i="1" dirty="0">
+                <a:solidFill>
+                  <a:schemeClr val="accent2"/>
+                </a:solidFill>
+              </a:rPr>
+              <a:t>automatic matching</a:t>
+            </a:r>
+            <a:endParaRPr lang="en-US" sz="1100" dirty="0"/>
+          </a:p>
+        </p:txBody>
+      </p:sp>
+      <p:sp>
+        <p:nvSpPr>
+          <p:cNvPr id="15" name="Shape 13"/>
           <p:cNvSpPr/>
           <p:nvPr/>
         </p:nvSpPr>
         <p:spPr>
           <a:xfrm>
-            <a:off x="2377440" y="2624328"/>
-            <a:ext cx="2011680" cy="548640"/>
+            <a:off x="1371600" y="2926080"/>
+            <a:ext cx="4023360" cy="0"/>
+          </a:xfrm>
+          <a:prstGeom prst="line">
+            <a:avLst/>
+          </a:prstGeom>
+          <a:noFill/>
+          <a:ln w="15875">
+            <a:solidFill>
+              <a:schemeClr val="accent4"/>
+            </a:solidFill>
+            <a:prstDash val="solid"/>
+          </a:ln>
+        </p:spPr>
+      </p:sp>
+      <p:sp>
+        <p:nvSpPr>
+          <p:cNvPr id="16" name="Shape 14"/>
+          <p:cNvSpPr/>
+          <p:nvPr/>
+        </p:nvSpPr>
+        <p:spPr>
+          <a:xfrm>
+            <a:off x="1271016" y="2926080"/>
+            <a:ext cx="201168" cy="164592"/>
+          </a:xfrm>
+          <a:prstGeom prst="downArrow">
+            <a:avLst/>
+          </a:prstGeom>
+          <a:solidFill>
+            <a:schemeClr val="accent4"/>
+          </a:solidFill>
+          <a:ln w="12700">
+            <a:solidFill>
+              <a:schemeClr val="accent4"/>
+            </a:solidFill>
+            <a:prstDash val="solid"/>
+          </a:ln>
+        </p:spPr>
+      </p:sp>
+      <p:sp>
+        <p:nvSpPr>
+          <p:cNvPr id="17" name="Shape 15"/>
+          <p:cNvSpPr/>
+          <p:nvPr/>
+        </p:nvSpPr>
+        <p:spPr>
+          <a:xfrm>
+            <a:off x="457200" y="3108960"/>
+            <a:ext cx="1828800" cy="566928"/>
           </a:xfrm>
           <a:prstGeom prst="roundRect">
             <a:avLst>
-              <a:gd name="adj" fmla="val 13333"/>
+              <a:gd name="adj" fmla="val 12903"/>
+            </a:avLst>
+          </a:prstGeom>
+          <a:solidFill>
+            <a:schemeClr val="bg2"/>
+          </a:solidFill>
+          <a:ln w="12700">
+            <a:solidFill>
+              <a:schemeClr val="bg2"/>
+            </a:solidFill>
+            <a:prstDash val="solid"/>
+          </a:ln>
+        </p:spPr>
+      </p:sp>
+      <p:sp>
+        <p:nvSpPr>
+          <p:cNvPr id="18" name="Text 16"/>
+          <p:cNvSpPr txBox="1"/>
+          <p:nvPr/>
+        </p:nvSpPr>
+        <p:spPr>
+          <a:xfrm>
+            <a:off x="502920" y="3108960"/>
+            <a:ext cx="1737360" cy="566928"/>
+          </a:xfrm>
+          <a:prstGeom prst="rect">
+            <a:avLst/>
+          </a:prstGeom>
+          <a:noFill/>
+          <a:ln/>
+        </p:spPr>
+        <p:txBody>
+          <a:bodyPr wrap="square" lIns="0" tIns="0" rIns="0" bIns="0" rtlCol="0" anchor="ctr"/>
+          <a:lstStyle/>
+          <a:p>
+            <a:pPr algn="ctr" indent="0" marL="0">
+              <a:buNone/>
+            </a:pPr>
+            <a:r>
+              <a:rPr lang="en-US" sz="1300" b="1" dirty="0">
+                <a:solidFill>
+                  <a:schemeClr val="accent1"/>
+                </a:solidFill>
+              </a:rPr>
+              <a:t>Auto-matched</a:t>
+            </a:r>
+            <a:endParaRPr lang="en-US" sz="1400" dirty="0"/>
+          </a:p>
+          <a:p>
+            <a:pPr algn="ctr" indent="0" marL="0">
+              <a:buNone/>
+            </a:pPr>
+            <a:r>
+              <a:rPr lang="en-US" sz="1100" dirty="0">
+                <a:solidFill>
+                  <a:schemeClr val="tx1"/>
+                </a:solidFill>
+              </a:rPr>
+              <a:t>same email or reg. no.</a:t>
+            </a:r>
+            <a:endParaRPr lang="en-US" sz="1400" dirty="0"/>
+          </a:p>
+        </p:txBody>
+      </p:sp>
+      <p:sp>
+        <p:nvSpPr>
+          <p:cNvPr id="19" name="Shape 17"/>
+          <p:cNvSpPr/>
+          <p:nvPr/>
+        </p:nvSpPr>
+        <p:spPr>
+          <a:xfrm>
+            <a:off x="3282696" y="2926080"/>
+            <a:ext cx="201168" cy="164592"/>
+          </a:xfrm>
+          <a:prstGeom prst="downArrow">
+            <a:avLst/>
+          </a:prstGeom>
+          <a:solidFill>
+            <a:schemeClr val="accent4"/>
+          </a:solidFill>
+          <a:ln w="12700">
+            <a:solidFill>
+              <a:schemeClr val="accent4"/>
+            </a:solidFill>
+            <a:prstDash val="solid"/>
+          </a:ln>
+        </p:spPr>
+      </p:sp>
+      <p:sp>
+        <p:nvSpPr>
+          <p:cNvPr id="20" name="Shape 18"/>
+          <p:cNvSpPr/>
+          <p:nvPr/>
+        </p:nvSpPr>
+        <p:spPr>
+          <a:xfrm>
+            <a:off x="2468880" y="3108960"/>
+            <a:ext cx="1828800" cy="566928"/>
+          </a:xfrm>
+          <a:prstGeom prst="roundRect">
+            <a:avLst>
+              <a:gd name="adj" fmla="val 12903"/>
+            </a:avLst>
+          </a:prstGeom>
+          <a:solidFill>
+            <a:schemeClr val="bg2"/>
+          </a:solidFill>
+          <a:ln w="12700">
+            <a:solidFill>
+              <a:schemeClr val="bg2"/>
+            </a:solidFill>
+            <a:prstDash val="solid"/>
+          </a:ln>
+        </p:spPr>
+      </p:sp>
+      <p:sp>
+        <p:nvSpPr>
+          <p:cNvPr id="21" name="Text 19"/>
+          <p:cNvSpPr txBox="1"/>
+          <p:nvPr/>
+        </p:nvSpPr>
+        <p:spPr>
+          <a:xfrm>
+            <a:off x="2514600" y="3108960"/>
+            <a:ext cx="1737360" cy="566928"/>
+          </a:xfrm>
+          <a:prstGeom prst="rect">
+            <a:avLst/>
+          </a:prstGeom>
+          <a:noFill/>
+          <a:ln/>
+        </p:spPr>
+        <p:txBody>
+          <a:bodyPr wrap="square" lIns="0" tIns="0" rIns="0" bIns="0" rtlCol="0" anchor="ctr"/>
+          <a:lstStyle/>
+          <a:p>
+            <a:pPr algn="ctr" indent="0" marL="0">
+              <a:buNone/>
+            </a:pPr>
+            <a:r>
+              <a:rPr lang="en-US" sz="1300" b="1" dirty="0">
+                <a:solidFill>
+                  <a:schemeClr val="accent1"/>
+                </a:solidFill>
+              </a:rPr>
+              <a:t>To review</a:t>
+            </a:r>
+            <a:endParaRPr lang="en-US" sz="1400" dirty="0"/>
+          </a:p>
+          <a:p>
+            <a:pPr algn="ctr" indent="0" marL="0">
+              <a:buNone/>
+            </a:pPr>
+            <a:r>
+              <a:rPr lang="en-US" sz="1100" dirty="0">
+                <a:solidFill>
+                  <a:schemeClr val="tx1"/>
+                </a:solidFill>
+              </a:rPr>
+              <a:t>steward decides, 1 click</a:t>
+            </a:r>
+            <a:endParaRPr lang="en-US" sz="1400" dirty="0"/>
+          </a:p>
+        </p:txBody>
+      </p:sp>
+      <p:sp>
+        <p:nvSpPr>
+          <p:cNvPr id="22" name="Shape 20"/>
+          <p:cNvSpPr/>
+          <p:nvPr/>
+        </p:nvSpPr>
+        <p:spPr>
+          <a:xfrm>
+            <a:off x="5294376" y="2926080"/>
+            <a:ext cx="201168" cy="164592"/>
+          </a:xfrm>
+          <a:prstGeom prst="downArrow">
+            <a:avLst/>
+          </a:prstGeom>
+          <a:solidFill>
+            <a:schemeClr val="accent4"/>
+          </a:solidFill>
+          <a:ln w="12700">
+            <a:solidFill>
+              <a:schemeClr val="accent4"/>
+            </a:solidFill>
+            <a:prstDash val="solid"/>
+          </a:ln>
+        </p:spPr>
+      </p:sp>
+      <p:sp>
+        <p:nvSpPr>
+          <p:cNvPr id="23" name="Shape 21"/>
+          <p:cNvSpPr/>
+          <p:nvPr/>
+        </p:nvSpPr>
+        <p:spPr>
+          <a:xfrm>
+            <a:off x="4480560" y="3108960"/>
+            <a:ext cx="1828800" cy="566928"/>
+          </a:xfrm>
+          <a:prstGeom prst="roundRect">
+            <a:avLst>
+              <a:gd name="adj" fmla="val 12903"/>
+            </a:avLst>
+          </a:prstGeom>
+          <a:solidFill>
+            <a:schemeClr val="bg2"/>
+          </a:solidFill>
+          <a:ln w="12700">
+            <a:solidFill>
+              <a:schemeClr val="bg2"/>
+            </a:solidFill>
+            <a:prstDash val="solid"/>
+          </a:ln>
+        </p:spPr>
+      </p:sp>
+      <p:sp>
+        <p:nvSpPr>
+          <p:cNvPr id="24" name="Text 22"/>
+          <p:cNvSpPr txBox="1"/>
+          <p:nvPr/>
+        </p:nvSpPr>
+        <p:spPr>
+          <a:xfrm>
+            <a:off x="4526280" y="3108960"/>
+            <a:ext cx="1737360" cy="566928"/>
+          </a:xfrm>
+          <a:prstGeom prst="rect">
+            <a:avLst/>
+          </a:prstGeom>
+          <a:noFill/>
+          <a:ln/>
+        </p:spPr>
+        <p:txBody>
+          <a:bodyPr wrap="square" lIns="0" tIns="0" rIns="0" bIns="0" rtlCol="0" anchor="ctr"/>
+          <a:lstStyle/>
+          <a:p>
+            <a:pPr algn="ctr" indent="0" marL="0">
+              <a:buNone/>
+            </a:pPr>
+            <a:r>
+              <a:rPr lang="en-US" sz="1300" b="1" dirty="0">
+                <a:solidFill>
+                  <a:schemeClr val="accent1"/>
+                </a:solidFill>
+              </a:rPr>
+              <a:t>New HCP</a:t>
+            </a:r>
+            <a:endParaRPr lang="en-US" sz="1400" dirty="0"/>
+          </a:p>
+          <a:p>
+            <a:pPr algn="ctr" indent="0" marL="0">
+              <a:buNone/>
+            </a:pPr>
+            <a:r>
+              <a:rPr lang="en-US" sz="1100" dirty="0">
+                <a:solidFill>
+                  <a:schemeClr val="tx1"/>
+                </a:solidFill>
+              </a:rPr>
+              <a:t>no plausible candidate</a:t>
+            </a:r>
+            <a:endParaRPr lang="en-US" sz="1400" dirty="0"/>
+          </a:p>
+        </p:txBody>
+      </p:sp>
+      <p:sp>
+        <p:nvSpPr>
+          <p:cNvPr id="25" name="Shape 23"/>
+          <p:cNvSpPr/>
+          <p:nvPr/>
+        </p:nvSpPr>
+        <p:spPr>
+          <a:xfrm>
+            <a:off x="1371600" y="3840480"/>
+            <a:ext cx="6263640" cy="0"/>
+          </a:xfrm>
+          <a:prstGeom prst="line">
+            <a:avLst/>
+          </a:prstGeom>
+          <a:noFill/>
+          <a:ln w="15875">
+            <a:solidFill>
+              <a:schemeClr val="accent4"/>
+            </a:solidFill>
+            <a:prstDash val="solid"/>
+          </a:ln>
+        </p:spPr>
+      </p:sp>
+      <p:sp>
+        <p:nvSpPr>
+          <p:cNvPr id="26" name="Shape 24"/>
+          <p:cNvSpPr/>
+          <p:nvPr/>
+        </p:nvSpPr>
+        <p:spPr>
+          <a:xfrm>
+            <a:off x="3282696" y="3840480"/>
+            <a:ext cx="201168" cy="201168"/>
+          </a:xfrm>
+          <a:prstGeom prst="downArrow">
+            <a:avLst/>
+          </a:prstGeom>
+          <a:solidFill>
+            <a:schemeClr val="accent4"/>
+          </a:solidFill>
+          <a:ln w="12700">
+            <a:solidFill>
+              <a:schemeClr val="accent4"/>
+            </a:solidFill>
+            <a:prstDash val="solid"/>
+          </a:ln>
+        </p:spPr>
+      </p:sp>
+      <p:sp>
+        <p:nvSpPr>
+          <p:cNvPr id="27" name="Shape 25"/>
+          <p:cNvSpPr/>
+          <p:nvPr/>
+        </p:nvSpPr>
+        <p:spPr>
+          <a:xfrm>
+            <a:off x="7534656" y="3840480"/>
+            <a:ext cx="201168" cy="201168"/>
+          </a:xfrm>
+          <a:prstGeom prst="downArrow">
+            <a:avLst/>
+          </a:prstGeom>
+          <a:solidFill>
+            <a:schemeClr val="accent2"/>
+          </a:solidFill>
+          <a:ln w="12700">
+            <a:solidFill>
+              <a:schemeClr val="accent2"/>
+            </a:solidFill>
+            <a:prstDash val="solid"/>
+          </a:ln>
+        </p:spPr>
+      </p:sp>
+      <p:sp>
+        <p:nvSpPr>
+          <p:cNvPr id="28" name="Shape 26"/>
+          <p:cNvSpPr/>
+          <p:nvPr/>
+        </p:nvSpPr>
+        <p:spPr>
+          <a:xfrm>
+            <a:off x="2148840" y="4114800"/>
+            <a:ext cx="2468880" cy="566928"/>
+          </a:xfrm>
+          <a:prstGeom prst="roundRect">
+            <a:avLst>
+              <a:gd name="adj" fmla="val 12903"/>
+            </a:avLst>
+          </a:prstGeom>
+          <a:solidFill>
+            <a:srgbClr val="E3ECF7"/>
+          </a:solidFill>
+          <a:ln w="12700">
+            <a:solidFill>
+              <a:srgbClr val="E3ECF7"/>
+            </a:solidFill>
+            <a:prstDash val="solid"/>
+          </a:ln>
+        </p:spPr>
+      </p:sp>
+      <p:sp>
+        <p:nvSpPr>
+          <p:cNvPr id="29" name="Text 27"/>
+          <p:cNvSpPr txBox="1"/>
+          <p:nvPr/>
+        </p:nvSpPr>
+        <p:spPr>
+          <a:xfrm>
+            <a:off x="2194560" y="4114800"/>
+            <a:ext cx="2377440" cy="566928"/>
+          </a:xfrm>
+          <a:prstGeom prst="rect">
+            <a:avLst/>
+          </a:prstGeom>
+          <a:noFill/>
+          <a:ln/>
+        </p:spPr>
+        <p:txBody>
+          <a:bodyPr wrap="square" lIns="0" tIns="0" rIns="0" bIns="0" rtlCol="0" anchor="ctr"/>
+          <a:lstStyle/>
+          <a:p>
+            <a:pPr algn="ctr" indent="0" marL="0">
+              <a:buNone/>
+            </a:pPr>
+            <a:r>
+              <a:rPr lang="en-US" sz="1300" b="1" dirty="0">
+                <a:solidFill>
+                  <a:schemeClr val="accent1"/>
+                </a:solidFill>
+              </a:rPr>
+              <a:t>Update Consent record</a:t>
+            </a:r>
+            <a:endParaRPr lang="en-US" sz="1400" dirty="0"/>
+          </a:p>
+          <a:p>
+            <a:pPr algn="ctr" indent="0" marL="0">
+              <a:buNone/>
+            </a:pPr>
+            <a:r>
+              <a:rPr lang="en-US" sz="1100" dirty="0">
+                <a:solidFill>
+                  <a:schemeClr val="tx1"/>
+                </a:solidFill>
+              </a:rPr>
+              <a:t>proof: text version, who, when, hash</a:t>
+            </a:r>
+            <a:endParaRPr lang="en-US" sz="1400" dirty="0"/>
+          </a:p>
+        </p:txBody>
+      </p:sp>
+      <p:sp>
+        <p:nvSpPr>
+          <p:cNvPr id="30" name="Shape 28"/>
+          <p:cNvSpPr/>
+          <p:nvPr/>
+        </p:nvSpPr>
+        <p:spPr>
+          <a:xfrm>
+            <a:off x="4681728" y="4261104"/>
+            <a:ext cx="274320" cy="274320"/>
+          </a:xfrm>
+          <a:prstGeom prst="rightArrow">
+            <a:avLst/>
+          </a:prstGeom>
+          <a:solidFill>
+            <a:schemeClr val="accent4"/>
+          </a:solidFill>
+          <a:ln w="12700">
+            <a:solidFill>
+              <a:schemeClr val="accent4"/>
+            </a:solidFill>
+            <a:prstDash val="solid"/>
+          </a:ln>
+        </p:spPr>
+      </p:sp>
+      <p:sp>
+        <p:nvSpPr>
+          <p:cNvPr id="31" name="Shape 29"/>
+          <p:cNvSpPr/>
+          <p:nvPr/>
+        </p:nvSpPr>
+        <p:spPr>
+          <a:xfrm>
+            <a:off x="5029200" y="4114800"/>
+            <a:ext cx="1600200" cy="566928"/>
+          </a:xfrm>
+          <a:prstGeom prst="roundRect">
+            <a:avLst>
+              <a:gd name="adj" fmla="val 12903"/>
+            </a:avLst>
+          </a:prstGeom>
+          <a:solidFill>
+            <a:schemeClr val="bg2"/>
+          </a:solidFill>
+          <a:ln w="12700">
+            <a:solidFill>
+              <a:schemeClr val="bg2"/>
+            </a:solidFill>
+            <a:prstDash val="solid"/>
+          </a:ln>
+        </p:spPr>
+      </p:sp>
+      <p:sp>
+        <p:nvSpPr>
+          <p:cNvPr id="32" name="Text 30"/>
+          <p:cNvSpPr txBox="1"/>
+          <p:nvPr/>
+        </p:nvSpPr>
+        <p:spPr>
+          <a:xfrm>
+            <a:off x="5074920" y="4114800"/>
+            <a:ext cx="1508760" cy="566928"/>
+          </a:xfrm>
+          <a:prstGeom prst="rect">
+            <a:avLst/>
+          </a:prstGeom>
+          <a:noFill/>
+          <a:ln/>
+        </p:spPr>
+        <p:txBody>
+          <a:bodyPr wrap="square" lIns="0" tIns="0" rIns="0" bIns="0" rtlCol="0" anchor="ctr"/>
+          <a:lstStyle/>
+          <a:p>
+            <a:pPr algn="ctr" indent="0" marL="0">
+              <a:buNone/>
+            </a:pPr>
+            <a:r>
+              <a:rPr lang="en-US" sz="1300" b="1" dirty="0">
+                <a:solidFill>
+                  <a:schemeClr val="accent1"/>
+                </a:solidFill>
+              </a:rPr>
+              <a:t>Sent to Gigya</a:t>
+            </a:r>
+            <a:endParaRPr lang="en-US" sz="1400" dirty="0"/>
+          </a:p>
+          <a:p>
+            <a:pPr algn="ctr" indent="0" marL="0">
+              <a:buNone/>
+            </a:pPr>
+            <a:r>
+              <a:rPr lang="en-US" sz="1100" dirty="0">
+                <a:solidFill>
+                  <a:schemeClr val="tx1"/>
+                </a:solidFill>
+              </a:rPr>
+              <a:t>marketing can communicate</a:t>
+            </a:r>
+            <a:endParaRPr lang="en-US" sz="1400" dirty="0"/>
+          </a:p>
+        </p:txBody>
+      </p:sp>
+      <p:sp>
+        <p:nvSpPr>
+          <p:cNvPr id="33" name="Shape 31"/>
+          <p:cNvSpPr/>
+          <p:nvPr/>
+        </p:nvSpPr>
+        <p:spPr>
+          <a:xfrm>
+            <a:off x="6720840" y="4114800"/>
+            <a:ext cx="1828800" cy="566928"/>
+          </a:xfrm>
+          <a:prstGeom prst="roundRect">
+            <a:avLst>
+              <a:gd name="adj" fmla="val 12903"/>
             </a:avLst>
           </a:prstGeom>
           <a:solidFill>
@@ -2915,14 +3532,14 @@
       </p:sp>
       <p:sp>
         <p:nvSpPr>
-          <p:cNvPr id="15" name="Text 13"/>
+          <p:cNvPr id="34" name="Text 32"/>
           <p:cNvSpPr txBox="1"/>
           <p:nvPr/>
         </p:nvSpPr>
         <p:spPr>
           <a:xfrm>
-            <a:off x="2423160" y="2624328"/>
-            <a:ext cx="1920240" cy="548640"/>
+            <a:off x="6766560" y="4114800"/>
+            <a:ext cx="1737360" cy="566928"/>
           </a:xfrm>
           <a:prstGeom prst="rect">
             <a:avLst/>
@@ -2943,7 +3560,7 @@
                   <a:schemeClr val="accent2"/>
                 </a:solidFill>
               </a:rPr>
-              <a:t>Automatic matching</a:t>
+              <a:t>Visit</a:t>
             </a:r>
             <a:endParaRPr lang="en-US" sz="1400" dirty="0"/>
           </a:p>
@@ -2957,7 +3574,7 @@
                   <a:schemeClr val="tx1"/>
                 </a:solidFill>
               </a:rPr>
-              <a:t>in the background, in seconds</a:t>
+              <a:t>created by Apex on the HCP</a:t>
             </a:r>
             <a:endParaRPr lang="en-US" sz="1400" dirty="0"/>
           </a:p>
@@ -2965,66 +3582,18 @@
       </p:sp>
       <p:sp>
         <p:nvSpPr>
-          <p:cNvPr id="16" name="Shape 14"/>
+          <p:cNvPr id="35" name="Shape 33"/>
           <p:cNvSpPr/>
           <p:nvPr/>
         </p:nvSpPr>
         <p:spPr>
           <a:xfrm>
-            <a:off x="1371600" y="3310128"/>
-            <a:ext cx="4023360" cy="0"/>
-          </a:xfrm>
-          <a:prstGeom prst="line">
-            <a:avLst/>
-          </a:prstGeom>
-          <a:noFill/>
-          <a:ln w="15875">
-            <a:solidFill>
-              <a:schemeClr val="accent4"/>
-            </a:solidFill>
-            <a:prstDash val="solid"/>
-          </a:ln>
-        </p:spPr>
-      </p:sp>
-      <p:sp>
-        <p:nvSpPr>
-          <p:cNvPr id="17" name="Shape 15"/>
-          <p:cNvSpPr/>
-          <p:nvPr/>
-        </p:nvSpPr>
-        <p:spPr>
-          <a:xfrm>
-            <a:off x="3282696" y="3191256"/>
-            <a:ext cx="201168" cy="182880"/>
-          </a:xfrm>
-          <a:prstGeom prst="downArrow">
-            <a:avLst/>
-          </a:prstGeom>
-          <a:solidFill>
-            <a:schemeClr val="accent4"/>
-          </a:solidFill>
-          <a:ln w="12700">
-            <a:solidFill>
-              <a:schemeClr val="accent4"/>
-            </a:solidFill>
-            <a:prstDash val="solid"/>
-          </a:ln>
-        </p:spPr>
-      </p:sp>
-      <p:sp>
-        <p:nvSpPr>
-          <p:cNvPr id="18" name="Shape 16"/>
-          <p:cNvSpPr/>
-          <p:nvPr/>
-        </p:nvSpPr>
-        <p:spPr>
-          <a:xfrm>
-            <a:off x="457200" y="3401568"/>
-            <a:ext cx="1828800" cy="548640"/>
+            <a:off x="6720840" y="1051560"/>
+            <a:ext cx="1965960" cy="2514600"/>
           </a:xfrm>
           <a:prstGeom prst="roundRect">
             <a:avLst>
-              <a:gd name="adj" fmla="val 13333"/>
+              <a:gd name="adj" fmla="val 3721"/>
             </a:avLst>
           </a:prstGeom>
           <a:solidFill>
@@ -3040,621 +3609,14 @@
       </p:sp>
       <p:sp>
         <p:nvSpPr>
-          <p:cNvPr id="19" name="Text 17"/>
-          <p:cNvSpPr txBox="1"/>
-          <p:nvPr/>
-        </p:nvSpPr>
-        <p:spPr>
-          <a:xfrm>
-            <a:off x="502920" y="3401568"/>
-            <a:ext cx="1737360" cy="548640"/>
-          </a:xfrm>
-          <a:prstGeom prst="rect">
-            <a:avLst/>
-          </a:prstGeom>
-          <a:noFill/>
-          <a:ln/>
-        </p:spPr>
-        <p:txBody>
-          <a:bodyPr wrap="square" lIns="0" tIns="0" rIns="0" bIns="0" rtlCol="0" anchor="ctr"/>
-          <a:lstStyle/>
-          <a:p>
-            <a:pPr algn="ctr" indent="0" marL="0">
-              <a:buNone/>
-            </a:pPr>
-            <a:r>
-              <a:rPr lang="en-US" sz="1300" b="1" dirty="0">
-                <a:solidFill>
-                  <a:schemeClr val="accent1"/>
-                </a:solidFill>
-              </a:rPr>
-              <a:t>Auto-matched</a:t>
-            </a:r>
-            <a:endParaRPr lang="en-US" sz="1400" dirty="0"/>
-          </a:p>
-          <a:p>
-            <a:pPr algn="ctr" indent="0" marL="0">
-              <a:buNone/>
-            </a:pPr>
-            <a:r>
-              <a:rPr lang="en-US" sz="1100" dirty="0">
-                <a:solidFill>
-                  <a:schemeClr val="tx1"/>
-                </a:solidFill>
-              </a:rPr>
-              <a:t>same email or reg. no.</a:t>
-            </a:r>
-            <a:endParaRPr lang="en-US" sz="1400" dirty="0"/>
-          </a:p>
-        </p:txBody>
-      </p:sp>
-      <p:sp>
-        <p:nvSpPr>
-          <p:cNvPr id="20" name="Shape 18"/>
-          <p:cNvSpPr/>
-          <p:nvPr/>
-        </p:nvSpPr>
-        <p:spPr>
-          <a:xfrm>
-            <a:off x="2468880" y="3401568"/>
-            <a:ext cx="1828800" cy="548640"/>
-          </a:xfrm>
-          <a:prstGeom prst="roundRect">
-            <a:avLst>
-              <a:gd name="adj" fmla="val 13333"/>
-            </a:avLst>
-          </a:prstGeom>
-          <a:solidFill>
-            <a:schemeClr val="bg2"/>
-          </a:solidFill>
-          <a:ln w="12700">
-            <a:solidFill>
-              <a:schemeClr val="bg2"/>
-            </a:solidFill>
-            <a:prstDash val="solid"/>
-          </a:ln>
-        </p:spPr>
-      </p:sp>
-      <p:sp>
-        <p:nvSpPr>
-          <p:cNvPr id="21" name="Text 19"/>
-          <p:cNvSpPr txBox="1"/>
-          <p:nvPr/>
-        </p:nvSpPr>
-        <p:spPr>
-          <a:xfrm>
-            <a:off x="2514600" y="3401568"/>
-            <a:ext cx="1737360" cy="548640"/>
-          </a:xfrm>
-          <a:prstGeom prst="rect">
-            <a:avLst/>
-          </a:prstGeom>
-          <a:noFill/>
-          <a:ln/>
-        </p:spPr>
-        <p:txBody>
-          <a:bodyPr wrap="square" lIns="0" tIns="0" rIns="0" bIns="0" rtlCol="0" anchor="ctr"/>
-          <a:lstStyle/>
-          <a:p>
-            <a:pPr algn="ctr" indent="0" marL="0">
-              <a:buNone/>
-            </a:pPr>
-            <a:r>
-              <a:rPr lang="en-US" sz="1300" b="1" dirty="0">
-                <a:solidFill>
-                  <a:schemeClr val="accent1"/>
-                </a:solidFill>
-              </a:rPr>
-              <a:t>To review</a:t>
-            </a:r>
-            <a:endParaRPr lang="en-US" sz="1400" dirty="0"/>
-          </a:p>
-          <a:p>
-            <a:pPr algn="ctr" indent="0" marL="0">
-              <a:buNone/>
-            </a:pPr>
-            <a:r>
-              <a:rPr lang="en-US" sz="1100" dirty="0">
-                <a:solidFill>
-                  <a:schemeClr val="tx1"/>
-                </a:solidFill>
-              </a:rPr>
-              <a:t>steward decides, 1 click</a:t>
-            </a:r>
-            <a:endParaRPr lang="en-US" sz="1400" dirty="0"/>
-          </a:p>
-        </p:txBody>
-      </p:sp>
-      <p:sp>
-        <p:nvSpPr>
-          <p:cNvPr id="22" name="Shape 20"/>
-          <p:cNvSpPr/>
-          <p:nvPr/>
-        </p:nvSpPr>
-        <p:spPr>
-          <a:xfrm>
-            <a:off x="4480560" y="3401568"/>
-            <a:ext cx="1828800" cy="548640"/>
-          </a:xfrm>
-          <a:prstGeom prst="roundRect">
-            <a:avLst>
-              <a:gd name="adj" fmla="val 13333"/>
-            </a:avLst>
-          </a:prstGeom>
-          <a:solidFill>
-            <a:schemeClr val="bg2"/>
-          </a:solidFill>
-          <a:ln w="12700">
-            <a:solidFill>
-              <a:schemeClr val="bg2"/>
-            </a:solidFill>
-            <a:prstDash val="solid"/>
-          </a:ln>
-        </p:spPr>
-      </p:sp>
-      <p:sp>
-        <p:nvSpPr>
-          <p:cNvPr id="23" name="Text 21"/>
-          <p:cNvSpPr txBox="1"/>
-          <p:nvPr/>
-        </p:nvSpPr>
-        <p:spPr>
-          <a:xfrm>
-            <a:off x="4526280" y="3401568"/>
-            <a:ext cx="1737360" cy="548640"/>
-          </a:xfrm>
-          <a:prstGeom prst="rect">
-            <a:avLst/>
-          </a:prstGeom>
-          <a:noFill/>
-          <a:ln/>
-        </p:spPr>
-        <p:txBody>
-          <a:bodyPr wrap="square" lIns="0" tIns="0" rIns="0" bIns="0" rtlCol="0" anchor="ctr"/>
-          <a:lstStyle/>
-          <a:p>
-            <a:pPr algn="ctr" indent="0" marL="0">
-              <a:buNone/>
-            </a:pPr>
-            <a:r>
-              <a:rPr lang="en-US" sz="1300" b="1" dirty="0">
-                <a:solidFill>
-                  <a:schemeClr val="accent1"/>
-                </a:solidFill>
-              </a:rPr>
-              <a:t>New HCP</a:t>
-            </a:r>
-            <a:endParaRPr lang="en-US" sz="1400" dirty="0"/>
-          </a:p>
-          <a:p>
-            <a:pPr algn="ctr" indent="0" marL="0">
-              <a:buNone/>
-            </a:pPr>
-            <a:r>
-              <a:rPr lang="en-US" sz="1100" dirty="0">
-                <a:solidFill>
-                  <a:schemeClr val="tx1"/>
-                </a:solidFill>
-              </a:rPr>
-              <a:t>no plausible candidate</a:t>
-            </a:r>
-            <a:endParaRPr lang="en-US" sz="1400" dirty="0"/>
-          </a:p>
-        </p:txBody>
-      </p:sp>
-      <p:sp>
-        <p:nvSpPr>
-          <p:cNvPr id="24" name="Shape 22"/>
-          <p:cNvSpPr/>
-          <p:nvPr/>
-        </p:nvSpPr>
-        <p:spPr>
-          <a:xfrm>
-            <a:off x="1371600" y="4041648"/>
-            <a:ext cx="6309360" cy="0"/>
-          </a:xfrm>
-          <a:prstGeom prst="line">
-            <a:avLst/>
-          </a:prstGeom>
-          <a:noFill/>
-          <a:ln w="15875">
-            <a:solidFill>
-              <a:schemeClr val="accent4"/>
-            </a:solidFill>
-            <a:prstDash val="solid"/>
-          </a:ln>
-        </p:spPr>
-      </p:sp>
-      <p:sp>
-        <p:nvSpPr>
-          <p:cNvPr id="25" name="Shape 23"/>
-          <p:cNvSpPr/>
-          <p:nvPr/>
-        </p:nvSpPr>
-        <p:spPr>
-          <a:xfrm>
-            <a:off x="3282696" y="4041648"/>
-            <a:ext cx="201168" cy="164592"/>
-          </a:xfrm>
-          <a:prstGeom prst="downArrow">
-            <a:avLst/>
-          </a:prstGeom>
-          <a:solidFill>
-            <a:schemeClr val="accent4"/>
-          </a:solidFill>
-          <a:ln w="12700">
-            <a:solidFill>
-              <a:schemeClr val="accent4"/>
-            </a:solidFill>
-            <a:prstDash val="solid"/>
-          </a:ln>
-        </p:spPr>
-      </p:sp>
-      <p:sp>
-        <p:nvSpPr>
-          <p:cNvPr id="26" name="Shape 24"/>
-          <p:cNvSpPr/>
-          <p:nvPr/>
-        </p:nvSpPr>
-        <p:spPr>
-          <a:xfrm>
-            <a:off x="7580376" y="4041648"/>
-            <a:ext cx="201168" cy="164592"/>
-          </a:xfrm>
-          <a:prstGeom prst="downArrow">
-            <a:avLst/>
-          </a:prstGeom>
-          <a:solidFill>
-            <a:schemeClr val="accent2"/>
-          </a:solidFill>
-          <a:ln w="12700">
-            <a:solidFill>
-              <a:schemeClr val="accent2"/>
-            </a:solidFill>
-            <a:prstDash val="solid"/>
-          </a:ln>
-        </p:spPr>
-      </p:sp>
-      <p:sp>
-        <p:nvSpPr>
-          <p:cNvPr id="27" name="Shape 25"/>
-          <p:cNvSpPr/>
-          <p:nvPr/>
-        </p:nvSpPr>
-        <p:spPr>
-          <a:xfrm>
-            <a:off x="2148840" y="4233672"/>
-            <a:ext cx="2468880" cy="502920"/>
-          </a:xfrm>
-          <a:prstGeom prst="roundRect">
-            <a:avLst>
-              <a:gd name="adj" fmla="val 14545"/>
-            </a:avLst>
-          </a:prstGeom>
-          <a:solidFill>
-            <a:srgbClr val="E3ECF7"/>
-          </a:solidFill>
-          <a:ln w="12700">
-            <a:solidFill>
-              <a:srgbClr val="E3ECF7"/>
-            </a:solidFill>
-            <a:prstDash val="solid"/>
-          </a:ln>
-        </p:spPr>
-      </p:sp>
-      <p:sp>
-        <p:nvSpPr>
-          <p:cNvPr id="28" name="Text 26"/>
-          <p:cNvSpPr txBox="1"/>
-          <p:nvPr/>
-        </p:nvSpPr>
-        <p:spPr>
-          <a:xfrm>
-            <a:off x="2194560" y="4233672"/>
-            <a:ext cx="2377440" cy="502920"/>
-          </a:xfrm>
-          <a:prstGeom prst="rect">
-            <a:avLst/>
-          </a:prstGeom>
-          <a:noFill/>
-          <a:ln/>
-        </p:spPr>
-        <p:txBody>
-          <a:bodyPr wrap="square" lIns="0" tIns="0" rIns="0" bIns="0" rtlCol="0" anchor="ctr"/>
-          <a:lstStyle/>
-          <a:p>
-            <a:pPr algn="ctr" indent="0" marL="0">
-              <a:buNone/>
-            </a:pPr>
-            <a:r>
-              <a:rPr lang="en-US" sz="1300" b="1" dirty="0">
-                <a:solidFill>
-                  <a:schemeClr val="accent1"/>
-                </a:solidFill>
-              </a:rPr>
-              <a:t>Consent record</a:t>
-            </a:r>
-            <a:endParaRPr lang="en-US" sz="1400" dirty="0"/>
-          </a:p>
-          <a:p>
-            <a:pPr algn="ctr" indent="0" marL="0">
-              <a:buNone/>
-            </a:pPr>
-            <a:r>
-              <a:rPr lang="en-US" sz="1100" dirty="0">
-                <a:solidFill>
-                  <a:schemeClr val="tx1"/>
-                </a:solidFill>
-              </a:rPr>
-              <a:t>proof: text version, who, when, hash</a:t>
-            </a:r>
-            <a:endParaRPr lang="en-US" sz="1400" dirty="0"/>
-          </a:p>
-        </p:txBody>
-      </p:sp>
-      <p:sp>
-        <p:nvSpPr>
-          <p:cNvPr id="29" name="Shape 27"/>
-          <p:cNvSpPr/>
-          <p:nvPr/>
-        </p:nvSpPr>
-        <p:spPr>
-          <a:xfrm>
-            <a:off x="4681728" y="4343400"/>
-            <a:ext cx="274320" cy="274320"/>
-          </a:xfrm>
-          <a:prstGeom prst="rightArrow">
-            <a:avLst/>
-          </a:prstGeom>
-          <a:solidFill>
-            <a:schemeClr val="accent4"/>
-          </a:solidFill>
-          <a:ln w="12700">
-            <a:solidFill>
-              <a:schemeClr val="accent4"/>
-            </a:solidFill>
-            <a:prstDash val="solid"/>
-          </a:ln>
-        </p:spPr>
-      </p:sp>
-      <p:sp>
-        <p:nvSpPr>
-          <p:cNvPr id="30" name="Shape 28"/>
-          <p:cNvSpPr/>
-          <p:nvPr/>
-        </p:nvSpPr>
-        <p:spPr>
-          <a:xfrm>
-            <a:off x="5029200" y="4233672"/>
-            <a:ext cx="1600200" cy="502920"/>
-          </a:xfrm>
-          <a:prstGeom prst="roundRect">
-            <a:avLst>
-              <a:gd name="adj" fmla="val 14545"/>
-            </a:avLst>
-          </a:prstGeom>
-          <a:solidFill>
-            <a:schemeClr val="bg2"/>
-          </a:solidFill>
-          <a:ln w="12700">
-            <a:solidFill>
-              <a:schemeClr val="bg2"/>
-            </a:solidFill>
-            <a:prstDash val="solid"/>
-          </a:ln>
-        </p:spPr>
-      </p:sp>
-      <p:sp>
-        <p:nvSpPr>
-          <p:cNvPr id="31" name="Text 29"/>
-          <p:cNvSpPr txBox="1"/>
-          <p:nvPr/>
-        </p:nvSpPr>
-        <p:spPr>
-          <a:xfrm>
-            <a:off x="5074920" y="4233672"/>
-            <a:ext cx="1508760" cy="502920"/>
-          </a:xfrm>
-          <a:prstGeom prst="rect">
-            <a:avLst/>
-          </a:prstGeom>
-          <a:noFill/>
-          <a:ln/>
-        </p:spPr>
-        <p:txBody>
-          <a:bodyPr wrap="square" lIns="0" tIns="0" rIns="0" bIns="0" rtlCol="0" anchor="ctr"/>
-          <a:lstStyle/>
-          <a:p>
-            <a:pPr algn="ctr" indent="0" marL="0">
-              <a:buNone/>
-            </a:pPr>
-            <a:r>
-              <a:rPr lang="en-US" sz="1300" b="1" dirty="0">
-                <a:solidFill>
-                  <a:schemeClr val="accent1"/>
-                </a:solidFill>
-              </a:rPr>
-              <a:t>Sent to Gigya</a:t>
-            </a:r>
-            <a:endParaRPr lang="en-US" sz="1400" dirty="0"/>
-          </a:p>
-          <a:p>
-            <a:pPr algn="ctr" indent="0" marL="0">
-              <a:buNone/>
-            </a:pPr>
-            <a:r>
-              <a:rPr lang="en-US" sz="1100" dirty="0">
-                <a:solidFill>
-                  <a:schemeClr val="tx1"/>
-                </a:solidFill>
-              </a:rPr>
-              <a:t>marketing can communicate</a:t>
-            </a:r>
-            <a:endParaRPr lang="en-US" sz="1400" dirty="0"/>
-          </a:p>
-        </p:txBody>
-      </p:sp>
-      <p:sp>
-        <p:nvSpPr>
-          <p:cNvPr id="32" name="Shape 30"/>
-          <p:cNvSpPr/>
-          <p:nvPr/>
-        </p:nvSpPr>
-        <p:spPr>
-          <a:xfrm>
-            <a:off x="6720840" y="4233672"/>
-            <a:ext cx="1828800" cy="502920"/>
-          </a:xfrm>
-          <a:prstGeom prst="roundRect">
-            <a:avLst>
-              <a:gd name="adj" fmla="val 14545"/>
-            </a:avLst>
-          </a:prstGeom>
-          <a:solidFill>
-            <a:srgbClr val="FBE3DC"/>
-          </a:solidFill>
-          <a:ln w="12700">
-            <a:solidFill>
-              <a:srgbClr val="FBE3DC"/>
-            </a:solidFill>
-            <a:prstDash val="solid"/>
-          </a:ln>
-        </p:spPr>
-      </p:sp>
-      <p:sp>
-        <p:nvSpPr>
-          <p:cNvPr id="33" name="Text 31"/>
-          <p:cNvSpPr txBox="1"/>
-          <p:nvPr/>
-        </p:nvSpPr>
-        <p:spPr>
-          <a:xfrm>
-            <a:off x="6766560" y="4233672"/>
-            <a:ext cx="1737360" cy="502920"/>
-          </a:xfrm>
-          <a:prstGeom prst="rect">
-            <a:avLst/>
-          </a:prstGeom>
-          <a:noFill/>
-          <a:ln/>
-        </p:spPr>
-        <p:txBody>
-          <a:bodyPr wrap="square" lIns="0" tIns="0" rIns="0" bIns="0" rtlCol="0" anchor="ctr"/>
-          <a:lstStyle/>
-          <a:p>
-            <a:pPr algn="ctr" indent="0" marL="0">
-              <a:buNone/>
-            </a:pPr>
-            <a:r>
-              <a:rPr lang="en-US" sz="1300" b="1" dirty="0">
-                <a:solidFill>
-                  <a:schemeClr val="accent2"/>
-                </a:solidFill>
-              </a:rPr>
-              <a:t>Visit</a:t>
-            </a:r>
-            <a:endParaRPr lang="en-US" sz="1400" dirty="0"/>
-          </a:p>
-          <a:p>
-            <a:pPr algn="ctr" indent="0" marL="0">
-              <a:buNone/>
-            </a:pPr>
-            <a:r>
-              <a:rPr lang="en-US" sz="1100" dirty="0">
-                <a:solidFill>
-                  <a:schemeClr val="tx1"/>
-                </a:solidFill>
-              </a:rPr>
-              <a:t>created by Apex on the HCP</a:t>
-            </a:r>
-            <a:endParaRPr lang="en-US" sz="1400" dirty="0"/>
-          </a:p>
-        </p:txBody>
-      </p:sp>
-      <p:sp>
-        <p:nvSpPr>
-          <p:cNvPr id="34" name="Shape 32"/>
-          <p:cNvSpPr/>
-          <p:nvPr/>
-        </p:nvSpPr>
-        <p:spPr>
-          <a:xfrm>
-            <a:off x="6720840" y="1005840"/>
-            <a:ext cx="1965960" cy="2743200"/>
-          </a:xfrm>
-          <a:prstGeom prst="roundRect">
-            <a:avLst>
-              <a:gd name="adj" fmla="val 3721"/>
-            </a:avLst>
-          </a:prstGeom>
-          <a:solidFill>
-            <a:schemeClr val="bg2"/>
-          </a:solidFill>
-          <a:ln w="12700">
-            <a:solidFill>
-              <a:schemeClr val="bg2"/>
-            </a:solidFill>
-            <a:prstDash val="solid"/>
-          </a:ln>
-        </p:spPr>
-      </p:sp>
-      <p:sp>
-        <p:nvSpPr>
-          <p:cNvPr id="35" name="Text 33"/>
-          <p:cNvSpPr txBox="1"/>
-          <p:nvPr/>
-        </p:nvSpPr>
-        <p:spPr>
-          <a:xfrm>
-            <a:off x="6858000" y="1143000"/>
-            <a:ext cx="1691640" cy="731520"/>
-          </a:xfrm>
-          <a:prstGeom prst="rect">
-            <a:avLst/>
-          </a:prstGeom>
-          <a:noFill/>
-          <a:ln/>
-        </p:spPr>
-        <p:txBody>
-          <a:bodyPr wrap="square" lIns="0" tIns="0" rIns="0" bIns="0" rtlCol="0" anchor="t"/>
-          <a:lstStyle/>
-          <a:p>
-            <a:pPr indent="0" marL="0">
-              <a:buNone/>
-            </a:pPr>
-            <a:r>
-              <a:rPr lang="en-US" sz="1200" b="1" dirty="0">
-                <a:solidFill>
-                  <a:schemeClr val="accent3"/>
-                </a:solidFill>
-              </a:rPr>
-              <a:t>Existing: </a:t>
-            </a:r>
-            <a:pPr indent="0" marL="0">
-              <a:buNone/>
-            </a:pPr>
-            <a:r>
-              <a:rPr lang="en-US" sz="1200" dirty="0">
-                <a:solidFill>
-                  <a:schemeClr val="tx1"/>
-                </a:solidFill>
-              </a:rPr>
-              <a:t>Congress and attendees (Pitcher)</a:t>
-            </a:r>
-            <a:endParaRPr lang="en-US" sz="1200" dirty="0"/>
-          </a:p>
-        </p:txBody>
-      </p:sp>
-      <p:sp>
-        <p:nvSpPr>
           <p:cNvPr id="36" name="Text 34"/>
           <p:cNvSpPr txBox="1"/>
           <p:nvPr/>
         </p:nvSpPr>
         <p:spPr>
           <a:xfrm>
-            <a:off x="6858000" y="1920240"/>
-            <a:ext cx="1691640" cy="914400"/>
+            <a:off x="6858000" y="1188720"/>
+            <a:ext cx="1691640" cy="685800"/>
           </a:xfrm>
           <a:prstGeom prst="rect">
             <a:avLst/>
@@ -3672,10 +3634,10 @@
             <a:r>
               <a:rPr lang="en-US" sz="1200" b="1" dirty="0">
                 <a:solidFill>
-                  <a:schemeClr val="accent2"/>
-                </a:solidFill>
-              </a:rPr>
-              <a:t>New: </a:t>
+                  <a:schemeClr val="accent3"/>
+                </a:solidFill>
+              </a:rPr>
+              <a:t>Existing: </a:t>
             </a:r>
             <a:pPr indent="0" marL="0">
               <a:buNone/>
@@ -3686,7 +3648,7 @@
                   <a:schemeClr val="tx1"/>
                 </a:solidFill>
               </a:rPr>
-              <a:t>Capture, matching, consent and Visit, in Salesforce from the browser</a:t>
+              <a:t>Congress and attendees (Pitcher)</a:t>
             </a:r>
             <a:endParaRPr lang="en-US" sz="1200" dirty="0"/>
           </a:p>
@@ -3700,8 +3662,55 @@
         </p:nvSpPr>
         <p:spPr>
           <a:xfrm>
-            <a:off x="6858000" y="2926080"/>
-            <a:ext cx="1691640" cy="731520"/>
+            <a:off x="6858000" y="1920240"/>
+            <a:ext cx="1691640" cy="868680"/>
+          </a:xfrm>
+          <a:prstGeom prst="rect">
+            <a:avLst/>
+          </a:prstGeom>
+          <a:noFill/>
+          <a:ln/>
+        </p:spPr>
+        <p:txBody>
+          <a:bodyPr wrap="square" lIns="0" tIns="0" rIns="0" bIns="0" rtlCol="0" anchor="t"/>
+          <a:lstStyle/>
+          <a:p>
+            <a:pPr indent="0" marL="0">
+              <a:buNone/>
+            </a:pPr>
+            <a:r>
+              <a:rPr lang="en-US" sz="1200" b="1" dirty="0">
+                <a:solidFill>
+                  <a:schemeClr val="accent2"/>
+                </a:solidFill>
+              </a:rPr>
+              <a:t>New: </a:t>
+            </a:r>
+            <a:pPr indent="0" marL="0">
+              <a:buNone/>
+            </a:pPr>
+            <a:r>
+              <a:rPr lang="en-US" sz="1200" dirty="0">
+                <a:solidFill>
+                  <a:schemeClr val="tx1"/>
+                </a:solidFill>
+              </a:rPr>
+              <a:t>Capture, matching and Visit, in Salesforce from the browser</a:t>
+            </a:r>
+            <a:endParaRPr lang="en-US" sz="1200" dirty="0"/>
+          </a:p>
+        </p:txBody>
+      </p:sp>
+      <p:sp>
+        <p:nvSpPr>
+          <p:cNvPr id="38" name="Text 36"/>
+          <p:cNvSpPr txBox="1"/>
+          <p:nvPr/>
+        </p:nvSpPr>
+        <p:spPr>
+          <a:xfrm>
+            <a:off x="6858000" y="2834640"/>
+            <a:ext cx="1691640" cy="640080"/>
           </a:xfrm>
           <a:prstGeom prst="rect">
             <a:avLst/>
@@ -4517,12 +4526,12 @@
         </p:nvSpPr>
         <p:spPr>
           <a:xfrm>
-            <a:off x="457200" y="1097280"/>
-            <a:ext cx="2468880" cy="1371600"/>
+            <a:off x="457200" y="1051560"/>
+            <a:ext cx="2468880" cy="1280160"/>
           </a:xfrm>
           <a:prstGeom prst="roundRect">
             <a:avLst>
-              <a:gd name="adj" fmla="val 5333"/>
+              <a:gd name="adj" fmla="val 5714"/>
             </a:avLst>
           </a:prstGeom>
           <a:solidFill>
@@ -4544,7 +4553,7 @@
         </p:nvSpPr>
         <p:spPr>
           <a:xfrm>
-            <a:off x="594360" y="1188720"/>
+            <a:off x="594360" y="1143000"/>
             <a:ext cx="2194560" cy="320040"/>
           </a:xfrm>
           <a:prstGeom prst="rect">
@@ -4566,7 +4575,7 @@
                   <a:schemeClr val="accent1"/>
                 </a:solidFill>
               </a:rPr>
-              <a:t>Congress</a:t>
+              <a:t>Attendee</a:t>
             </a:r>
             <a:endParaRPr lang="en-US" sz="1500" dirty="0"/>
           </a:p>
@@ -4580,7 +4589,7 @@
         </p:nvSpPr>
         <p:spPr>
           <a:xfrm>
-            <a:off x="594360" y="1508760"/>
+            <a:off x="594360" y="1463040"/>
             <a:ext cx="2194560" cy="274320"/>
           </a:xfrm>
           <a:prstGeom prst="rect">
@@ -4616,8 +4625,8 @@
         </p:nvSpPr>
         <p:spPr>
           <a:xfrm>
-            <a:off x="594360" y="1783080"/>
-            <a:ext cx="2194560" cy="594360"/>
+            <a:off x="594360" y="1737360"/>
+            <a:ext cx="2194560" cy="502920"/>
           </a:xfrm>
           <a:prstGeom prst="rect">
             <a:avLst/>
@@ -4638,7 +4647,7 @@
                   <a:schemeClr val="tx1"/>
                 </a:solidFill>
               </a:rPr>
-              <a:t>Event, dates, venue</a:t>
+              <a:t>HCP invited to the congress</a:t>
             </a:r>
             <a:endParaRPr lang="en-US" sz="1200" dirty="0"/>
           </a:p>
@@ -4652,12 +4661,12 @@
         </p:nvSpPr>
         <p:spPr>
           <a:xfrm>
-            <a:off x="3337560" y="1097280"/>
-            <a:ext cx="2468880" cy="1371600"/>
+            <a:off x="3337560" y="1051560"/>
+            <a:ext cx="2468880" cy="1280160"/>
           </a:xfrm>
           <a:prstGeom prst="roundRect">
             <a:avLst>
-              <a:gd name="adj" fmla="val 5333"/>
+              <a:gd name="adj" fmla="val 5714"/>
             </a:avLst>
           </a:prstGeom>
           <a:solidFill>
@@ -4679,7 +4688,7 @@
         </p:nvSpPr>
         <p:spPr>
           <a:xfrm>
-            <a:off x="3474720" y="1188720"/>
+            <a:off x="3474720" y="1143000"/>
             <a:ext cx="2194560" cy="320040"/>
           </a:xfrm>
           <a:prstGeom prst="rect">
@@ -4701,7 +4710,7 @@
                   <a:schemeClr val="accent1"/>
                 </a:solidFill>
               </a:rPr>
-              <a:t>Attendee</a:t>
+              <a:t>Congress</a:t>
             </a:r>
             <a:endParaRPr lang="en-US" sz="1500" dirty="0"/>
           </a:p>
@@ -4715,7 +4724,7 @@
         </p:nvSpPr>
         <p:spPr>
           <a:xfrm>
-            <a:off x="3474720" y="1508760"/>
+            <a:off x="3474720" y="1463040"/>
             <a:ext cx="2194560" cy="274320"/>
           </a:xfrm>
           <a:prstGeom prst="rect">
@@ -4751,8 +4760,8 @@
         </p:nvSpPr>
         <p:spPr>
           <a:xfrm>
-            <a:off x="3474720" y="1783080"/>
-            <a:ext cx="2194560" cy="594360"/>
+            <a:off x="3474720" y="1737360"/>
+            <a:ext cx="2194560" cy="502920"/>
           </a:xfrm>
           <a:prstGeom prst="rect">
             <a:avLst/>
@@ -4773,7 +4782,7 @@
                   <a:schemeClr val="tx1"/>
                 </a:solidFill>
               </a:rPr>
-              <a:t>HCP invited to the congress</a:t>
+              <a:t>Event, dates, venue</a:t>
             </a:r>
             <a:endParaRPr lang="en-US" sz="1200" dirty="0"/>
           </a:p>
@@ -4787,12 +4796,12 @@
         </p:nvSpPr>
         <p:spPr>
           <a:xfrm>
-            <a:off x="6217920" y="1097280"/>
-            <a:ext cx="2468880" cy="1371600"/>
+            <a:off x="6217920" y="1051560"/>
+            <a:ext cx="2468880" cy="1280160"/>
           </a:xfrm>
           <a:prstGeom prst="roundRect">
             <a:avLst>
-              <a:gd name="adj" fmla="val 5333"/>
+              <a:gd name="adj" fmla="val 5714"/>
             </a:avLst>
           </a:prstGeom>
           <a:solidFill>
@@ -4814,7 +4823,7 @@
         </p:nvSpPr>
         <p:spPr>
           <a:xfrm>
-            <a:off x="6355080" y="1188720"/>
+            <a:off x="6355080" y="1143000"/>
             <a:ext cx="2194560" cy="320040"/>
           </a:xfrm>
           <a:prstGeom prst="rect">
@@ -4850,7 +4859,7 @@
         </p:nvSpPr>
         <p:spPr>
           <a:xfrm>
-            <a:off x="6355080" y="1508760"/>
+            <a:off x="6355080" y="1463040"/>
             <a:ext cx="2194560" cy="274320"/>
           </a:xfrm>
           <a:prstGeom prst="rect">
@@ -4886,8 +4895,8 @@
         </p:nvSpPr>
         <p:spPr>
           <a:xfrm>
-            <a:off x="6355080" y="1783080"/>
-            <a:ext cx="2194560" cy="594360"/>
+            <a:off x="6355080" y="1737360"/>
+            <a:ext cx="2194560" cy="502920"/>
           </a:xfrm>
           <a:prstGeom prst="rect">
             <a:avLst/>
@@ -4908,7 +4917,7 @@
                   <a:schemeClr val="tx1"/>
                 </a:solidFill>
               </a:rPr>
-              <a:t>One record per sign-up, matched to the HCP</a:t>
+              <a:t>One record per sign-up, linked to the congress</a:t>
             </a:r>
             <a:endParaRPr lang="en-US" sz="1200" dirty="0"/>
           </a:p>
@@ -4922,12 +4931,123 @@
         </p:nvSpPr>
         <p:spPr>
           <a:xfrm>
-            <a:off x="457200" y="3063240"/>
-            <a:ext cx="2468880" cy="1463040"/>
+            <a:off x="2971800" y="1554480"/>
+            <a:ext cx="320040" cy="274320"/>
+          </a:xfrm>
+          <a:prstGeom prst="leftArrow">
+            <a:avLst/>
+          </a:prstGeom>
+          <a:solidFill>
+            <a:schemeClr val="accent4"/>
+          </a:solidFill>
+          <a:ln w="12700">
+            <a:solidFill>
+              <a:schemeClr val="accent4"/>
+            </a:solidFill>
+            <a:prstDash val="solid"/>
+          </a:ln>
+        </p:spPr>
+      </p:sp>
+      <p:sp>
+        <p:nvSpPr>
+          <p:cNvPr id="16" name="Shape 14"/>
+          <p:cNvSpPr/>
+          <p:nvPr/>
+        </p:nvSpPr>
+        <p:spPr>
+          <a:xfrm>
+            <a:off x="5852160" y="1554480"/>
+            <a:ext cx="320040" cy="274320"/>
+          </a:xfrm>
+          <a:prstGeom prst="rightArrow">
+            <a:avLst/>
+          </a:prstGeom>
+          <a:solidFill>
+            <a:schemeClr val="accent4"/>
+          </a:solidFill>
+          <a:ln w="12700">
+            <a:solidFill>
+              <a:schemeClr val="accent4"/>
+            </a:solidFill>
+            <a:prstDash val="solid"/>
+          </a:ln>
+        </p:spPr>
+      </p:sp>
+      <p:sp>
+        <p:nvSpPr>
+          <p:cNvPr id="17" name="Shape 15"/>
+          <p:cNvSpPr/>
+          <p:nvPr/>
+        </p:nvSpPr>
+        <p:spPr>
+          <a:xfrm>
+            <a:off x="7315200" y="2395728"/>
+            <a:ext cx="274320" cy="457200"/>
+          </a:xfrm>
+          <a:prstGeom prst="downArrow">
+            <a:avLst/>
+          </a:prstGeom>
+          <a:solidFill>
+            <a:schemeClr val="accent2"/>
+          </a:solidFill>
+          <a:ln w="12700">
+            <a:solidFill>
+              <a:schemeClr val="accent2"/>
+            </a:solidFill>
+            <a:prstDash val="solid"/>
+          </a:ln>
+        </p:spPr>
+      </p:sp>
+      <p:sp>
+        <p:nvSpPr>
+          <p:cNvPr id="18" name="Text 16"/>
+          <p:cNvSpPr txBox="1"/>
+          <p:nvPr/>
+        </p:nvSpPr>
+        <p:spPr>
+          <a:xfrm>
+            <a:off x="7680960" y="2468880"/>
+            <a:ext cx="1005840" cy="274320"/>
+          </a:xfrm>
+          <a:prstGeom prst="rect">
+            <a:avLst/>
+          </a:prstGeom>
+          <a:noFill/>
+          <a:ln/>
+        </p:spPr>
+        <p:txBody>
+          <a:bodyPr wrap="square" lIns="0" tIns="0" rIns="0" bIns="0" rtlCol="0" anchor="t"/>
+          <a:lstStyle/>
+          <a:p>
+            <a:pPr indent="0" marL="0">
+              <a:buNone/>
+            </a:pPr>
+            <a:r>
+              <a:rPr lang="en-US" sz="1100" i="1" dirty="0">
+                <a:solidFill>
+                  <a:schemeClr val="accent2"/>
+                </a:solidFill>
+              </a:rPr>
+              <a:t>after match</a:t>
+            </a:r>
+            <a:endParaRPr lang="en-US" sz="1100" dirty="0"/>
+          </a:p>
+        </p:txBody>
+      </p:sp>
+      <p:sp>
+        <p:nvSpPr>
+          <p:cNvPr id="19" name="Shape 17"/>
+          <p:cNvSpPr/>
+          <p:nvPr/>
+        </p:nvSpPr>
+        <p:spPr>
+          <a:xfrm>
+            <a:off x="457200" y="2926080"/>
+            <a:ext cx="2468880" cy="1280160"/>
           </a:xfrm>
           <a:prstGeom prst="roundRect">
             <a:avLst>
-              <a:gd name="adj" fmla="val 5000"/>
+              <a:gd name="adj" fmla="val 5714"/>
             </a:avLst>
           </a:prstGeom>
           <a:solidFill>
@@ -4943,13 +5063,13 @@
       </p:sp>
       <p:sp>
         <p:nvSpPr>
-          <p:cNvPr id="16" name="Text 14"/>
+          <p:cNvPr id="20" name="Text 18"/>
           <p:cNvSpPr txBox="1"/>
           <p:nvPr/>
         </p:nvSpPr>
         <p:spPr>
           <a:xfrm>
-            <a:off x="594360" y="3154680"/>
+            <a:off x="594360" y="3017520"/>
             <a:ext cx="2194560" cy="320040"/>
           </a:xfrm>
           <a:prstGeom prst="rect">
@@ -4971,7 +5091,7 @@
                   <a:schemeClr val="accent2"/>
                 </a:solidFill>
               </a:rPr>
-              <a:t>Consent</a:t>
+              <a:t>Presentation (Visit)</a:t>
             </a:r>
             <a:endParaRPr lang="en-US" sz="1500" dirty="0"/>
           </a:p>
@@ -4979,13 +5099,13 @@
       </p:sp>
       <p:sp>
         <p:nvSpPr>
-          <p:cNvPr id="17" name="Text 15"/>
+          <p:cNvPr id="21" name="Text 19"/>
           <p:cNvSpPr txBox="1"/>
           <p:nvPr/>
         </p:nvSpPr>
         <p:spPr>
           <a:xfrm>
-            <a:off x="594360" y="3474720"/>
+            <a:off x="594360" y="3337560"/>
             <a:ext cx="2194560" cy="274320"/>
           </a:xfrm>
           <a:prstGeom prst="rect">
@@ -5007,7 +5127,7 @@
                   <a:schemeClr val="accent4"/>
                 </a:solidFill>
               </a:rPr>
-              <a:t>New</a:t>
+              <a:t>Existing - type Congress / Training</a:t>
             </a:r>
             <a:endParaRPr lang="en-US" sz="1100" dirty="0"/>
           </a:p>
@@ -5015,14 +5135,14 @@
       </p:sp>
       <p:sp>
         <p:nvSpPr>
-          <p:cNvPr id="18" name="Text 16"/>
+          <p:cNvPr id="22" name="Text 20"/>
           <p:cNvSpPr txBox="1"/>
           <p:nvPr/>
         </p:nvSpPr>
         <p:spPr>
           <a:xfrm>
-            <a:off x="594360" y="3749040"/>
-            <a:ext cx="2194560" cy="685800"/>
+            <a:off x="594360" y="3611880"/>
+            <a:ext cx="2194560" cy="502920"/>
           </a:xfrm>
           <a:prstGeom prst="rect">
             <a:avLst/>
@@ -5043,7 +5163,7 @@
                   <a:schemeClr val="tx1"/>
                 </a:solidFill>
               </a:rPr>
-              <a:t>HCP, status, text version, who, when, hash. Valid after email Confirm or signature, sent to Gigya</a:t>
+              <a:t>Created by Apex once the Capture is matched</a:t>
             </a:r>
             <a:endParaRPr lang="en-US" sz="1200" dirty="0"/>
           </a:p>
@@ -5051,18 +5171,153 @@
       </p:sp>
       <p:sp>
         <p:nvSpPr>
-          <p:cNvPr id="19" name="Shape 17"/>
+          <p:cNvPr id="23" name="Shape 21"/>
           <p:cNvSpPr/>
           <p:nvPr/>
         </p:nvSpPr>
         <p:spPr>
           <a:xfrm>
-            <a:off x="3337560" y="3063240"/>
-            <a:ext cx="2468880" cy="1463040"/>
+            <a:off x="3337560" y="2926080"/>
+            <a:ext cx="2468880" cy="1280160"/>
           </a:xfrm>
           <a:prstGeom prst="roundRect">
             <a:avLst>
-              <a:gd name="adj" fmla="val 5000"/>
+              <a:gd name="adj" fmla="val 5714"/>
+            </a:avLst>
+          </a:prstGeom>
+          <a:solidFill>
+            <a:srgbClr val="E3ECF7"/>
+          </a:solidFill>
+          <a:ln w="12700">
+            <a:solidFill>
+              <a:srgbClr val="E3ECF7"/>
+            </a:solidFill>
+            <a:prstDash val="solid"/>
+          </a:ln>
+        </p:spPr>
+      </p:sp>
+      <p:sp>
+        <p:nvSpPr>
+          <p:cNvPr id="24" name="Text 22"/>
+          <p:cNvSpPr txBox="1"/>
+          <p:nvPr/>
+        </p:nvSpPr>
+        <p:spPr>
+          <a:xfrm>
+            <a:off x="3474720" y="3017520"/>
+            <a:ext cx="2194560" cy="320040"/>
+          </a:xfrm>
+          <a:prstGeom prst="rect">
+            <a:avLst/>
+          </a:prstGeom>
+          <a:noFill/>
+          <a:ln/>
+        </p:spPr>
+        <p:txBody>
+          <a:bodyPr wrap="square" lIns="0" tIns="0" rIns="0" bIns="0" rtlCol="0" anchor="t"/>
+          <a:lstStyle/>
+          <a:p>
+            <a:pPr indent="0" marL="0">
+              <a:buNone/>
+            </a:pPr>
+            <a:r>
+              <a:rPr lang="en-US" sz="1500" b="1" dirty="0">
+                <a:solidFill>
+                  <a:schemeClr val="accent1"/>
+                </a:solidFill>
+              </a:rPr>
+              <a:t>Consent</a:t>
+            </a:r>
+            <a:endParaRPr lang="en-US" sz="1500" dirty="0"/>
+          </a:p>
+        </p:txBody>
+      </p:sp>
+      <p:sp>
+        <p:nvSpPr>
+          <p:cNvPr id="25" name="Text 23"/>
+          <p:cNvSpPr txBox="1"/>
+          <p:nvPr/>
+        </p:nvSpPr>
+        <p:spPr>
+          <a:xfrm>
+            <a:off x="3474720" y="3337560"/>
+            <a:ext cx="2194560" cy="274320"/>
+          </a:xfrm>
+          <a:prstGeom prst="rect">
+            <a:avLst/>
+          </a:prstGeom>
+          <a:noFill/>
+          <a:ln/>
+        </p:spPr>
+        <p:txBody>
+          <a:bodyPr wrap="square" lIns="0" tIns="0" rIns="0" bIns="0" rtlCol="0" anchor="t"/>
+          <a:lstStyle/>
+          <a:p>
+            <a:pPr indent="0" marL="0">
+              <a:buNone/>
+            </a:pPr>
+            <a:r>
+              <a:rPr lang="en-US" sz="1100" i="1" dirty="0">
+                <a:solidFill>
+                  <a:schemeClr val="accent4"/>
+                </a:solidFill>
+              </a:rPr>
+              <a:t>Existing</a:t>
+            </a:r>
+            <a:endParaRPr lang="en-US" sz="1100" dirty="0"/>
+          </a:p>
+        </p:txBody>
+      </p:sp>
+      <p:sp>
+        <p:nvSpPr>
+          <p:cNvPr id="26" name="Text 24"/>
+          <p:cNvSpPr txBox="1"/>
+          <p:nvPr/>
+        </p:nvSpPr>
+        <p:spPr>
+          <a:xfrm>
+            <a:off x="3474720" y="3611880"/>
+            <a:ext cx="2194560" cy="502920"/>
+          </a:xfrm>
+          <a:prstGeom prst="rect">
+            <a:avLst/>
+          </a:prstGeom>
+          <a:noFill/>
+          <a:ln/>
+        </p:spPr>
+        <p:txBody>
+          <a:bodyPr wrap="square" lIns="0" tIns="0" rIns="0" bIns="0" rtlCol="0" anchor="t"/>
+          <a:lstStyle/>
+          <a:p>
+            <a:pPr indent="0" marL="0">
+              <a:buNone/>
+            </a:pPr>
+            <a:r>
+              <a:rPr lang="en-US" sz="1200" dirty="0">
+                <a:solidFill>
+                  <a:schemeClr val="tx1"/>
+                </a:solidFill>
+              </a:rPr>
+              <a:t>Updated after match, sent to Gigya. Proof: text version, who, when, hash</a:t>
+            </a:r>
+            <a:endParaRPr lang="en-US" sz="1200" dirty="0"/>
+          </a:p>
+        </p:txBody>
+      </p:sp>
+      <p:sp>
+        <p:nvSpPr>
+          <p:cNvPr id="27" name="Shape 25"/>
+          <p:cNvSpPr/>
+          <p:nvPr/>
+        </p:nvSpPr>
+        <p:spPr>
+          <a:xfrm>
+            <a:off x="6217920" y="2926080"/>
+            <a:ext cx="2468880" cy="1280160"/>
+          </a:xfrm>
+          <a:prstGeom prst="roundRect">
+            <a:avLst>
+              <a:gd name="adj" fmla="val 5714"/>
             </a:avLst>
           </a:prstGeom>
           <a:solidFill>
@@ -5078,13 +5333,13 @@
       </p:sp>
       <p:sp>
         <p:nvSpPr>
-          <p:cNvPr id="20" name="Text 18"/>
+          <p:cNvPr id="28" name="Text 26"/>
           <p:cNvSpPr txBox="1"/>
           <p:nvPr/>
         </p:nvSpPr>
         <p:spPr>
           <a:xfrm>
-            <a:off x="3474720" y="3154680"/>
+            <a:off x="6355080" y="3017520"/>
             <a:ext cx="2194560" cy="320040"/>
           </a:xfrm>
           <a:prstGeom prst="rect">
@@ -5114,13 +5369,13 @@
       </p:sp>
       <p:sp>
         <p:nvSpPr>
-          <p:cNvPr id="21" name="Text 19"/>
+          <p:cNvPr id="29" name="Text 27"/>
           <p:cNvSpPr txBox="1"/>
           <p:nvPr/>
         </p:nvSpPr>
         <p:spPr>
           <a:xfrm>
-            <a:off x="3474720" y="3474720"/>
+            <a:off x="6355080" y="3337560"/>
             <a:ext cx="2194560" cy="274320"/>
           </a:xfrm>
           <a:prstGeom prst="rect">
@@ -5150,14 +5405,14 @@
       </p:sp>
       <p:sp>
         <p:nvSpPr>
-          <p:cNvPr id="22" name="Text 20"/>
+          <p:cNvPr id="30" name="Text 28"/>
           <p:cNvSpPr txBox="1"/>
           <p:nvPr/>
         </p:nvSpPr>
         <p:spPr>
           <a:xfrm>
-            <a:off x="3474720" y="3749040"/>
-            <a:ext cx="2194560" cy="685800"/>
+            <a:off x="6355080" y="3611880"/>
+            <a:ext cx="2194560" cy="502920"/>
           </a:xfrm>
           <a:prstGeom prst="rect">
             <a:avLst/>
@@ -5186,151 +5441,16 @@
       </p:sp>
       <p:sp>
         <p:nvSpPr>
-          <p:cNvPr id="23" name="Shape 21"/>
+          <p:cNvPr id="31" name="Shape 29"/>
           <p:cNvSpPr/>
           <p:nvPr/>
         </p:nvSpPr>
         <p:spPr>
           <a:xfrm>
-            <a:off x="6217920" y="3063240"/>
-            <a:ext cx="2468880" cy="1463040"/>
-          </a:xfrm>
-          <a:prstGeom prst="roundRect">
-            <a:avLst>
-              <a:gd name="adj" fmla="val 5000"/>
-            </a:avLst>
-          </a:prstGeom>
-          <a:solidFill>
-            <a:srgbClr val="FBE3DC"/>
-          </a:solidFill>
-          <a:ln w="12700">
-            <a:solidFill>
-              <a:srgbClr val="FBE3DC"/>
-            </a:solidFill>
-            <a:prstDash val="solid"/>
-          </a:ln>
-        </p:spPr>
-      </p:sp>
-      <p:sp>
-        <p:nvSpPr>
-          <p:cNvPr id="24" name="Text 22"/>
-          <p:cNvSpPr txBox="1"/>
-          <p:nvPr/>
-        </p:nvSpPr>
-        <p:spPr>
-          <a:xfrm>
-            <a:off x="6355080" y="3154680"/>
-            <a:ext cx="2194560" cy="320040"/>
-          </a:xfrm>
-          <a:prstGeom prst="rect">
-            <a:avLst/>
-          </a:prstGeom>
-          <a:noFill/>
-          <a:ln/>
-        </p:spPr>
-        <p:txBody>
-          <a:bodyPr wrap="square" lIns="0" tIns="0" rIns="0" bIns="0" rtlCol="0" anchor="t"/>
-          <a:lstStyle/>
-          <a:p>
-            <a:pPr indent="0" marL="0">
-              <a:buNone/>
-            </a:pPr>
-            <a:r>
-              <a:rPr lang="en-US" sz="1500" b="1" dirty="0">
-                <a:solidFill>
-                  <a:schemeClr val="accent2"/>
-                </a:solidFill>
-              </a:rPr>
-              <a:t>Presentation (Visit)</a:t>
-            </a:r>
-            <a:endParaRPr lang="en-US" sz="1500" dirty="0"/>
-          </a:p>
-        </p:txBody>
-      </p:sp>
-      <p:sp>
-        <p:nvSpPr>
-          <p:cNvPr id="25" name="Text 23"/>
-          <p:cNvSpPr txBox="1"/>
-          <p:nvPr/>
-        </p:nvSpPr>
-        <p:spPr>
-          <a:xfrm>
-            <a:off x="6355080" y="3474720"/>
-            <a:ext cx="2194560" cy="274320"/>
-          </a:xfrm>
-          <a:prstGeom prst="rect">
-            <a:avLst/>
-          </a:prstGeom>
-          <a:noFill/>
-          <a:ln/>
-        </p:spPr>
-        <p:txBody>
-          <a:bodyPr wrap="square" lIns="0" tIns="0" rIns="0" bIns="0" rtlCol="0" anchor="t"/>
-          <a:lstStyle/>
-          <a:p>
-            <a:pPr indent="0" marL="0">
-              <a:buNone/>
-            </a:pPr>
-            <a:r>
-              <a:rPr lang="en-US" sz="1100" i="1" dirty="0">
-                <a:solidFill>
-                  <a:schemeClr val="accent4"/>
-                </a:solidFill>
-              </a:rPr>
-              <a:t>Existing - type Congress / Training</a:t>
-            </a:r>
-            <a:endParaRPr lang="en-US" sz="1100" dirty="0"/>
-          </a:p>
-        </p:txBody>
-      </p:sp>
-      <p:sp>
-        <p:nvSpPr>
-          <p:cNvPr id="26" name="Text 24"/>
-          <p:cNvSpPr txBox="1"/>
-          <p:nvPr/>
-        </p:nvSpPr>
-        <p:spPr>
-          <a:xfrm>
-            <a:off x="6355080" y="3749040"/>
-            <a:ext cx="2194560" cy="685800"/>
-          </a:xfrm>
-          <a:prstGeom prst="rect">
-            <a:avLst/>
-          </a:prstGeom>
-          <a:noFill/>
-          <a:ln/>
-        </p:spPr>
-        <p:txBody>
-          <a:bodyPr wrap="square" lIns="0" tIns="0" rIns="0" bIns="0" rtlCol="0" anchor="t"/>
-          <a:lstStyle/>
-          <a:p>
-            <a:pPr indent="0" marL="0">
-              <a:buNone/>
-            </a:pPr>
-            <a:r>
-              <a:rPr lang="en-US" sz="1200" dirty="0">
-                <a:solidFill>
-                  <a:schemeClr val="tx1"/>
-                </a:solidFill>
-              </a:rPr>
-              <a:t>Created by Apex once the Capture is matched</a:t>
-            </a:r>
-            <a:endParaRPr lang="en-US" sz="1200" dirty="0"/>
-          </a:p>
-        </p:txBody>
-      </p:sp>
-      <p:sp>
-        <p:nvSpPr>
-          <p:cNvPr id="27" name="Shape 25"/>
-          <p:cNvSpPr/>
-          <p:nvPr/>
-        </p:nvSpPr>
-        <p:spPr>
-          <a:xfrm>
-            <a:off x="2971800" y="1645920"/>
+            <a:off x="5852160" y="3429000"/>
             <a:ext cx="320040" cy="274320"/>
           </a:xfrm>
-          <a:prstGeom prst="rightArrow">
+          <a:prstGeom prst="leftArrow">
             <a:avLst/>
           </a:prstGeom>
           <a:solidFill>
@@ -5346,22 +5466,20 @@
       </p:sp>
       <p:sp>
         <p:nvSpPr>
-          <p:cNvPr id="28" name="Shape 26"/>
+          <p:cNvPr id="32" name="Shape 30"/>
           <p:cNvSpPr/>
           <p:nvPr/>
         </p:nvSpPr>
         <p:spPr>
           <a:xfrm>
-            <a:off x="5852160" y="1645920"/>
-            <a:ext cx="320040" cy="274320"/>
-          </a:xfrm>
-          <a:prstGeom prst="rightArrow">
-            <a:avLst/>
-          </a:prstGeom>
-          <a:solidFill>
-            <a:schemeClr val="accent4"/>
-          </a:solidFill>
-          <a:ln w="12700">
+            <a:off x="7452360" y="4206240"/>
+            <a:ext cx="0" cy="228600"/>
+          </a:xfrm>
+          <a:prstGeom prst="line">
+            <a:avLst/>
+          </a:prstGeom>
+          <a:noFill/>
+          <a:ln w="25400">
             <a:solidFill>
               <a:schemeClr val="accent4"/>
             </a:solidFill>
@@ -5371,107 +5489,20 @@
       </p:sp>
       <p:sp>
         <p:nvSpPr>
-          <p:cNvPr id="29" name="Shape 27"/>
+          <p:cNvPr id="33" name="Shape 31"/>
           <p:cNvSpPr/>
           <p:nvPr/>
         </p:nvSpPr>
         <p:spPr>
           <a:xfrm>
-            <a:off x="7315200" y="2560320"/>
-            <a:ext cx="274320" cy="411480"/>
-          </a:xfrm>
-          <a:prstGeom prst="downArrow">
-            <a:avLst/>
-          </a:prstGeom>
-          <a:solidFill>
-            <a:schemeClr val="accent2"/>
-          </a:solidFill>
-          <a:ln w="12700">
-            <a:solidFill>
-              <a:schemeClr val="accent2"/>
-            </a:solidFill>
-            <a:prstDash val="solid"/>
-          </a:ln>
-        </p:spPr>
-      </p:sp>
-      <p:sp>
-        <p:nvSpPr>
-          <p:cNvPr id="30" name="Shape 28"/>
-          <p:cNvSpPr/>
-          <p:nvPr/>
-        </p:nvSpPr>
-        <p:spPr>
-          <a:xfrm flipH="1">
-            <a:off x="2743200" y="2606040"/>
-            <a:ext cx="3566160" cy="411480"/>
+            <a:off x="1691640" y="4434840"/>
+            <a:ext cx="5760720" cy="0"/>
           </a:xfrm>
           <a:prstGeom prst="line">
             <a:avLst/>
           </a:prstGeom>
           <a:noFill/>
           <a:ln w="25400">
-            <a:solidFill>
-              <a:schemeClr val="accent2"/>
-            </a:solidFill>
-            <a:prstDash val="solid"/>
-            <a:tailEnd type="triangle"/>
-          </a:ln>
-        </p:spPr>
-      </p:sp>
-      <p:sp>
-        <p:nvSpPr>
-          <p:cNvPr id="31" name="Text 29"/>
-          <p:cNvSpPr txBox="1"/>
-          <p:nvPr/>
-        </p:nvSpPr>
-        <p:spPr>
-          <a:xfrm>
-            <a:off x="3931920" y="2487168"/>
-            <a:ext cx="1188720" cy="274320"/>
-          </a:xfrm>
-          <a:prstGeom prst="rect">
-            <a:avLst/>
-          </a:prstGeom>
-          <a:noFill/>
-          <a:ln/>
-        </p:spPr>
-        <p:txBody>
-          <a:bodyPr wrap="square" lIns="0" tIns="0" rIns="0" bIns="0" rtlCol="0" anchor="t"/>
-          <a:lstStyle/>
-          <a:p>
-            <a:pPr algn="ctr" indent="0" marL="0">
-              <a:buNone/>
-            </a:pPr>
-            <a:r>
-              <a:rPr lang="en-US" sz="1100" i="1" dirty="0">
-                <a:solidFill>
-                  <a:schemeClr val="accent2"/>
-                </a:solidFill>
-              </a:rPr>
-              <a:t>after match</a:t>
-            </a:r>
-            <a:endParaRPr lang="en-US" sz="1100" dirty="0"/>
-          </a:p>
-        </p:txBody>
-      </p:sp>
-      <p:sp>
-        <p:nvSpPr>
-          <p:cNvPr id="32" name="Shape 30"/>
-          <p:cNvSpPr/>
-          <p:nvPr/>
-        </p:nvSpPr>
-        <p:spPr>
-          <a:xfrm>
-            <a:off x="2971800" y="3657600"/>
-            <a:ext cx="320040" cy="274320"/>
-          </a:xfrm>
-          <a:prstGeom prst="rightArrow">
-            <a:avLst/>
-          </a:prstGeom>
-          <a:solidFill>
-            <a:schemeClr val="accent4"/>
-          </a:solidFill>
-          <a:ln w="12700">
             <a:solidFill>
               <a:schemeClr val="accent4"/>
             </a:solidFill>
@@ -5481,38 +5512,37 @@
       </p:sp>
       <p:sp>
         <p:nvSpPr>
-          <p:cNvPr id="33" name="Shape 31"/>
+          <p:cNvPr id="34" name="Shape 32"/>
           <p:cNvSpPr/>
           <p:nvPr/>
         </p:nvSpPr>
         <p:spPr>
-          <a:xfrm>
-            <a:off x="5852160" y="3657600"/>
-            <a:ext cx="320040" cy="274320"/>
-          </a:xfrm>
-          <a:prstGeom prst="leftArrow">
-            <a:avLst/>
-          </a:prstGeom>
-          <a:solidFill>
-            <a:schemeClr val="accent4"/>
-          </a:solidFill>
-          <a:ln w="12700">
+          <a:xfrm flipV="1">
+            <a:off x="1691640" y="4206240"/>
+            <a:ext cx="0" cy="228600"/>
+          </a:xfrm>
+          <a:prstGeom prst="line">
+            <a:avLst/>
+          </a:prstGeom>
+          <a:noFill/>
+          <a:ln w="25400">
             <a:solidFill>
               <a:schemeClr val="accent4"/>
             </a:solidFill>
             <a:prstDash val="solid"/>
+            <a:tailEnd type="triangle"/>
           </a:ln>
         </p:spPr>
       </p:sp>
       <p:sp>
         <p:nvSpPr>
-          <p:cNvPr id="34" name="Text 32"/>
+          <p:cNvPr id="35" name="Text 33"/>
           <p:cNvSpPr txBox="1"/>
           <p:nvPr/>
         </p:nvSpPr>
         <p:spPr>
           <a:xfrm>
-            <a:off x="457200" y="4709160"/>
+            <a:off x="457200" y="4663440"/>
             <a:ext cx="3657600" cy="274320"/>
           </a:xfrm>
           <a:prstGeom prst="rect">
@@ -6408,7 +6438,7 @@
                   <a:schemeClr val="tx1"/>
                 </a:solidFill>
               </a:rPr>
-              <a:t>HCP activity history, KPIs, reports and dashboards</a:t>
+              <a:t>HCP activity history, Engagement Plan, KPIs, reports, dashboards</a:t>
             </a:r>
             <a:endParaRPr lang="en-US" sz="1300" dirty="0"/>
           </a:p>

</xml_diff>